<commit_message>
Center CrossWOZ on dialogue data, original evaluation and practical use
</commit_message>
<xml_diff>
--- a/slides/datasets-in-10-minutes-crosswoz.pptx
+++ b/slides/datasets-in-10-minutes-crosswoz.pptx
@@ -35,7 +35,6 @@
     <p:sldId id="283" r:id="rId33"/>
     <p:sldId id="284" r:id="rId34"/>
     <p:sldId id="285" r:id="rId35"/>
-    <p:sldId id="286" r:id="rId36"/>
     <p:sldId id="288" r:id="rId38"/>
     <p:sldId id="289" r:id="rId39"/>
     <p:sldId id="290" r:id="rId40"/>
@@ -62,7 +61,6 @@
     <p:sldId id="313" r:id="rId63"/>
     <p:sldId id="314" r:id="rId64"/>
     <p:sldId id="315" r:id="rId65"/>
-    <p:sldId id="316" r:id="rId66"/>
   </p:sldIdLst>
   <p:sldSz cx="9144000" cy="5143500" type="screen16x9"/>
   <p:notesSz cx="6858000" cy="9144000"/>
@@ -19175,7 +19173,7 @@
 </p:sld>
 </file>
 
-<file path=ppt/slides/slide31.xml><?xml version="1.0" encoding="utf-8"?>
+<file path=ppt/slides/slide32.xml><?xml version="1.0" encoding="utf-8"?>
 <p:sld xmlns:a="http://schemas.openxmlformats.org/drawingml/2006/main" xmlns:p="http://schemas.openxmlformats.org/presentationml/2006/main" xmlns:r="http://schemas.openxmlformats.org/officeDocument/2006/relationships">
   <p:cSld>
     <p:spTree>
@@ -19228,7 +19226,7 @@
                 <a:ea typeface="Noto Sans CJK JP"/>
                 <a:cs typeface="Noto Sans"/>
               </a:rPr>
-              <a:t>CLEVAでは、履歴から応答を生成する</a:t>
+              <a:t>公式データと対話システムの実装を入手する</a:t>
             </a:r>
           </a:p>
         </p:txBody>
@@ -19281,7 +19279,7 @@
                 <a:ea typeface="Noto Sans CJK JP"/>
                 <a:cs typeface="Noto Sans"/>
               </a:rPr>
-              <a:t>CLEVAは、中国語モデルの評価にCrossWOZを採用した。会話の履歴を入力し、次に案内役が返す応答を生成する課題である。</a:t>
+              <a:t>公式リポジトリのdata/crosswozから、train・val・testのZIPと施設DBを取得できる。各ZIPには、対話IDをキーとしたJSON辞書が入っている。</a:t>
             </a:r>
           </a:p>
           <a:p>
@@ -19311,7 +19309,7 @@
                 <a:ea typeface="Noto Sans CJK JP"/>
                 <a:cs typeface="Noto Sans"/>
               </a:rPr>
-              <a:t>公開実装は、各システム発話の直前までの会話と、収録された応答を組にする。</a:t>
+              <a:t>自然言語理解、状態追跡、対話方策、応答生成を組み合わせる実装も公開されている。</a:t>
             </a:r>
           </a:p>
           <a:p>
@@ -19341,7 +19339,7 @@
                 <a:ea typeface="Noto Sans CJK JP"/>
                 <a:cs typeface="Noto Sans"/>
               </a:rPr>
-              <a:t>CLEVAで使われた対話の全体や、抽出範囲は公開説明から確認できない。元のCrossWOZは、公式リポジトリから取得できる。</a:t>
+              <a:t>リポジトリのライセンスはApache License 2.0。構築論文はCC BY 4.0で公開され、著者はデータやコードを使う場合の論文引用を求めている。</a:t>
             </a:r>
           </a:p>
         </p:txBody>
@@ -19402,8 +19400,8 @@
         </p:nvSpPr>
         <p:spPr>
           <a:xfrm>
-            <a:off x="502920" y="4699000"/>
-            <a:ext cx="8183879" cy="431800"/>
+            <a:off x="502920" y="4508500"/>
+            <a:ext cx="8183879" cy="558800"/>
           </a:xfrm>
           <a:prstGeom prst="rect">
             <a:avLst/>
@@ -19438,7 +19436,7 @@
               <a:rPr sz="830">
                 <a:latin typeface="Noto Sans CJK JP"/>
               </a:rPr>
-              <a:t>[1] Stanford CRFM (2023). HELM: CLEVA dialogue generation scenario.</a:t>
+              <a:t>[1] Zhu et al. (2020). CrossWOZ: official repository.</a:t>
             </a:r>
           </a:p>
           <a:p>
@@ -19455,7 +19453,40 @@
                 <a:latin typeface="Noto Sans CJK JP"/>
                 <a:hlinkClick r:id="rId2"/>
               </a:rPr>
-              <a:t>https://github.com/stanford-crfm/helm/blob/v0.4.0/src/helm/benchmark/scenarios/cleva_scenario.py</a:t>
+              <a:t>https://github.com/thu-coai/CrossWOZ</a:t>
+            </a:r>
+          </a:p>
+          <a:p>
+            <a:pPr>
+              <a:spcBef>
+                <a:spcPts val="0"/>
+              </a:spcBef>
+              <a:spcAft>
+                <a:spcPts val="0"/>
+              </a:spcAft>
+            </a:pPr>
+            <a:r>
+              <a:rPr sz="830">
+                <a:latin typeface="Noto Sans CJK JP"/>
+              </a:rPr>
+              <a:t>[2] 本資料の利用許諾・帰属表示（Apache 2.0）。</a:t>
+            </a:r>
+          </a:p>
+          <a:p>
+            <a:pPr>
+              <a:spcBef>
+                <a:spcPts val="0"/>
+              </a:spcBef>
+              <a:spcAft>
+                <a:spcPts val="0"/>
+              </a:spcAft>
+            </a:pPr>
+            <a:r>
+              <a:rPr sz="830">
+                <a:latin typeface="Noto Sans CJK JP"/>
+                <a:hlinkClick r:id="rId3"/>
+              </a:rPr>
+              <a:t>https://datasets-in-10-minutes.sasakiy84.net/assets/crosswoz-notices.zip</a:t>
             </a:r>
           </a:p>
         </p:txBody>
@@ -19521,7 +19552,7 @@
                 <a:ea typeface="Noto Sans CJK JP"/>
                 <a:cs typeface="Noto Sans"/>
               </a:rPr>
-              <a:t>公式データと対話システムの実装を入手する</a:t>
+              <a:t>文脈と状態を使う、領域横断の対話データ</a:t>
             </a:r>
           </a:p>
         </p:txBody>
@@ -19550,91 +19581,91 @@
           <a:p>
             <a:pPr marL="457200" indent="-355600">
               <a:lnSpc>
-                <a:spcPts val="2379"/>
+                <a:spcPts val="2439"/>
               </a:lnSpc>
               <a:spcAft>
                 <a:spcPts val="700"/>
               </a:spcAft>
-              <a:buSzPct val="66500"/>
+              <a:buSzPct val="64878"/>
               <a:buFont typeface="Noto Sans CJK JP"/>
               <a:buChar char="●"/>
-              <a:defRPr sz="2000" b="0">
-                <a:solidFill>
-                  <a:srgbClr val="303437"/>
-                </a:solidFill>
-                <a:latin typeface="Noto Sans"/>
-              </a:defRPr>
-            </a:pPr>
-            <a:r>
-              <a:rPr sz="2000" b="0" lang="ja-JP" altLang="en-US">
-                <a:solidFill>
-                  <a:srgbClr val="303437"/>
-                </a:solidFill>
-                <a:latin typeface="Noto Sans"/>
-                <a:ea typeface="Noto Sans CJK JP"/>
-                <a:cs typeface="Noto Sans"/>
-              </a:rPr>
-              <a:t>公式リポジトリのdata/crosswozから、train・val・testのZIPと施設DBを取得できる。各ZIPには、対話IDをキーとしたJSON辞書が入っている。</a:t>
+              <a:defRPr sz="2050" b="0">
+                <a:solidFill>
+                  <a:srgbClr val="303437"/>
+                </a:solidFill>
+                <a:latin typeface="Noto Sans"/>
+              </a:defRPr>
+            </a:pPr>
+            <a:r>
+              <a:rPr sz="2050" b="0" lang="ja-JP" altLang="en-US">
+                <a:solidFill>
+                  <a:srgbClr val="303437"/>
+                </a:solidFill>
+                <a:latin typeface="Noto Sans"/>
+                <a:ea typeface="Noto Sans CJK JP"/>
+                <a:cs typeface="Noto Sans"/>
+              </a:rPr>
+              <a:t>CrossWOZは、5領域の旅行案内を6,012対話にまとめ、目標・状態・対話行為・施設DBを対応させた中国語データセットである。</a:t>
             </a:r>
           </a:p>
           <a:p>
             <a:pPr marL="457200" indent="-355600">
               <a:lnSpc>
-                <a:spcPts val="2379"/>
+                <a:spcPts val="2439"/>
               </a:lnSpc>
               <a:spcAft>
                 <a:spcPts val="700"/>
               </a:spcAft>
-              <a:buSzPct val="66500"/>
+              <a:buSzPct val="64878"/>
               <a:buFont typeface="Noto Sans CJK JP"/>
               <a:buChar char="●"/>
-              <a:defRPr sz="2000" b="0">
-                <a:solidFill>
-                  <a:srgbClr val="303437"/>
-                </a:solidFill>
-                <a:latin typeface="Noto Sans"/>
-              </a:defRPr>
-            </a:pPr>
-            <a:r>
-              <a:rPr sz="2000" b="0" lang="ja-JP" altLang="en-US">
-                <a:solidFill>
-                  <a:srgbClr val="303437"/>
-                </a:solidFill>
-                <a:latin typeface="Noto Sans"/>
-                <a:ea typeface="Noto Sans CJK JP"/>
-                <a:cs typeface="Noto Sans"/>
-              </a:rPr>
-              <a:t>自然言語理解、状態追跡、対話方策、応答生成を組み合わせる実装も公開されている。</a:t>
+              <a:defRPr sz="2050" b="0">
+                <a:solidFill>
+                  <a:srgbClr val="303437"/>
+                </a:solidFill>
+                <a:latin typeface="Noto Sans"/>
+              </a:defRPr>
+            </a:pPr>
+            <a:r>
+              <a:rPr sz="2050" b="0" lang="ja-JP" altLang="en-US">
+                <a:solidFill>
+                  <a:srgbClr val="303437"/>
+                </a:solidFill>
+                <a:latin typeface="Noto Sans"/>
+                <a:ea typeface="Noto Sans CJK JP"/>
+                <a:cs typeface="Noto Sans"/>
+              </a:rPr>
+              <a:t>一つの施設の回答から、周辺の施設や施設間の移動へと条件がつながる。施設間に依存関係のある旅行目標では、状態追跡の正解率が低かった。</a:t>
             </a:r>
           </a:p>
           <a:p>
             <a:pPr marL="457200" indent="-355600">
               <a:lnSpc>
-                <a:spcPts val="2379"/>
-              </a:lnSpc>
-              <a:spcAft>
-                <a:spcPts val="0"/>
-              </a:spcAft>
-              <a:buSzPct val="66500"/>
+                <a:spcPts val="2439"/>
+              </a:lnSpc>
+              <a:spcAft>
+                <a:spcPts val="0"/>
+              </a:spcAft>
+              <a:buSzPct val="64878"/>
               <a:buFont typeface="Noto Sans CJK JP"/>
               <a:buChar char="●"/>
-              <a:defRPr sz="2000" b="0">
-                <a:solidFill>
-                  <a:srgbClr val="303437"/>
-                </a:solidFill>
-                <a:latin typeface="Noto Sans"/>
-              </a:defRPr>
-            </a:pPr>
-            <a:r>
-              <a:rPr sz="2000" b="0" lang="ja-JP" altLang="en-US">
-                <a:solidFill>
-                  <a:srgbClr val="303437"/>
-                </a:solidFill>
-                <a:latin typeface="Noto Sans"/>
-                <a:ea typeface="Noto Sans CJK JP"/>
-                <a:cs typeface="Noto Sans"/>
-              </a:rPr>
-              <a:t>リポジトリのライセンスはApache License 2.0。構築論文はCC BY 4.0で公開され、著者はデータやコードを使う場合の論文引用を求めている。</a:t>
+              <a:defRPr sz="2050" b="0">
+                <a:solidFill>
+                  <a:srgbClr val="303437"/>
+                </a:solidFill>
+                <a:latin typeface="Noto Sans"/>
+              </a:defRPr>
+            </a:pPr>
+            <a:r>
+              <a:rPr sz="2050" b="0" lang="ja-JP" altLang="en-US">
+                <a:solidFill>
+                  <a:srgbClr val="303437"/>
+                </a:solidFill>
+                <a:latin typeface="Noto Sans"/>
+                <a:ea typeface="Noto Sans CJK JP"/>
+                <a:cs typeface="Noto Sans"/>
+              </a:rPr>
+              <a:t>目標や状態の注釈は対話システムの各段階の評価に使える。収録された会話と応答は、履歴から次の発話を生成する課題にも使える。</a:t>
             </a:r>
           </a:p>
         </p:txBody>
@@ -19695,8 +19726,8 @@
         </p:nvSpPr>
         <p:spPr>
           <a:xfrm>
-            <a:off x="502920" y="4508500"/>
-            <a:ext cx="8183879" cy="558800"/>
+            <a:off x="502920" y="4699000"/>
+            <a:ext cx="8183879" cy="431800"/>
           </a:xfrm>
           <a:prstGeom prst="rect">
             <a:avLst/>
@@ -19731,7 +19762,7 @@
               <a:rPr sz="830">
                 <a:latin typeface="Noto Sans CJK JP"/>
               </a:rPr>
-              <a:t>[1] Zhu et al. (2020). CrossWOZ: official repository.</a:t>
+              <a:t>[1] Zhu et al. (2020). CrossWOZ: A Large-Scale Chinese Cross-Domain Task-Oriented Dialogue Dataset.</a:t>
             </a:r>
           </a:p>
           <a:p>
@@ -19748,40 +19779,7 @@
                 <a:latin typeface="Noto Sans CJK JP"/>
                 <a:hlinkClick r:id="rId2"/>
               </a:rPr>
-              <a:t>https://github.com/thu-coai/CrossWOZ</a:t>
-            </a:r>
-          </a:p>
-          <a:p>
-            <a:pPr>
-              <a:spcBef>
-                <a:spcPts val="0"/>
-              </a:spcBef>
-              <a:spcAft>
-                <a:spcPts val="0"/>
-              </a:spcAft>
-            </a:pPr>
-            <a:r>
-              <a:rPr sz="830">
-                <a:latin typeface="Noto Sans CJK JP"/>
-              </a:rPr>
-              <a:t>[2] 本資料の利用許諾・帰属表示（Apache 2.0）。</a:t>
-            </a:r>
-          </a:p>
-          <a:p>
-            <a:pPr>
-              <a:spcBef>
-                <a:spcPts val="0"/>
-              </a:spcBef>
-              <a:spcAft>
-                <a:spcPts val="0"/>
-              </a:spcAft>
-            </a:pPr>
-            <a:r>
-              <a:rPr sz="830">
-                <a:latin typeface="Noto Sans CJK JP"/>
-                <a:hlinkClick r:id="rId3"/>
-              </a:rPr>
-              <a:t>https://datasets-in-10-minutes.sasakiy84.net/assets/crosswoz-notices.zip</a:t>
+              <a:t>https://aclanthology.org/2020.tacl-1.19/</a:t>
             </a:r>
           </a:p>
         </p:txBody>
@@ -19816,158 +19814,45 @@
         </p:nvSpPr>
         <p:spPr>
           <a:xfrm>
-            <a:off x="468172" y="650138"/>
-            <a:ext cx="8206740" cy="616305"/>
+            <a:off x="548640" y="2484835"/>
+            <a:ext cx="8046720" cy="585216"/>
           </a:xfrm>
         </p:spPr>
         <p:txBody>
-          <a:bodyPr wrap="square" lIns="0" rIns="0" tIns="0" bIns="0">
+          <a:bodyPr wrap="square" lIns="0" rIns="0" tIns="0" bIns="0" anchor="ctr">
             <a:noAutofit/>
           </a:bodyPr>
           <a:lstStyle/>
           <a:p>
-            <a:pPr algn="l">
+            <a:pPr algn="ctr">
               <a:lnSpc>
                 <a:spcPct val="110000"/>
               </a:lnSpc>
               <a:buNone/>
-              <a:defRPr sz="2800" b="0">
-                <a:solidFill>
-                  <a:srgbClr val="303437"/>
-                </a:solidFill>
-                <a:latin typeface="Noto Sans"/>
-              </a:defRPr>
-            </a:pPr>
-            <a:r>
-              <a:rPr sz="2800" b="1" lang="ja-JP" altLang="en-US">
-                <a:solidFill>
-                  <a:srgbClr val="303437"/>
-                </a:solidFill>
-                <a:latin typeface="Noto Sans"/>
-                <a:ea typeface="Noto Sans CJK JP"/>
-                <a:cs typeface="Noto Sans"/>
-              </a:rPr>
-              <a:t>文脈と状態を使う、領域横断の対話データ</a:t>
+              <a:defRPr sz="3600" b="0">
+                <a:solidFill>
+                  <a:srgbClr val="303437"/>
+                </a:solidFill>
+                <a:latin typeface="Noto Sans"/>
+              </a:defRPr>
+            </a:pPr>
+            <a:r>
+              <a:rPr sz="3600" b="1" lang="ja-JP" altLang="en-US">
+                <a:solidFill>
+                  <a:srgbClr val="303437"/>
+                </a:solidFill>
+                <a:latin typeface="Noto Sans"/>
+                <a:ea typeface="Noto Sans CJK JP"/>
+                <a:cs typeface="Noto Sans"/>
+              </a:rPr>
+              <a:t>Appendix</a:t>
             </a:r>
           </a:p>
         </p:txBody>
       </p:sp>
       <p:sp>
         <p:nvSpPr>
-          <p:cNvPr id="3" name="Text Placeholder 2"/>
-          <p:cNvSpPr>
-            <a:spLocks noGrp="1"/>
-          </p:cNvSpPr>
-          <p:nvPr>
-            <p:ph type="body" idx="1"/>
-          </p:nvPr>
-        </p:nvSpPr>
-        <p:spPr>
-          <a:xfrm>
-            <a:off x="594360" y="1463040"/>
-            <a:ext cx="7955279" cy="3044952"/>
-          </a:xfrm>
-        </p:spPr>
-        <p:txBody>
-          <a:bodyPr wrap="square" tIns="91440" bIns="91440">
-            <a:noAutofit/>
-          </a:bodyPr>
-          <a:lstStyle/>
-          <a:p>
-            <a:pPr marL="457200" indent="-355600">
-              <a:lnSpc>
-                <a:spcPts val="2439"/>
-              </a:lnSpc>
-              <a:spcAft>
-                <a:spcPts val="700"/>
-              </a:spcAft>
-              <a:buSzPct val="64878"/>
-              <a:buFont typeface="Noto Sans CJK JP"/>
-              <a:buChar char="●"/>
-              <a:defRPr sz="2050" b="0">
-                <a:solidFill>
-                  <a:srgbClr val="303437"/>
-                </a:solidFill>
-                <a:latin typeface="Noto Sans"/>
-              </a:defRPr>
-            </a:pPr>
-            <a:r>
-              <a:rPr sz="2050" b="0" lang="ja-JP" altLang="en-US">
-                <a:solidFill>
-                  <a:srgbClr val="303437"/>
-                </a:solidFill>
-                <a:latin typeface="Noto Sans"/>
-                <a:ea typeface="Noto Sans CJK JP"/>
-                <a:cs typeface="Noto Sans"/>
-              </a:rPr>
-              <a:t>CrossWOZは、5領域の旅行案内を6,012対話にまとめ、目標・状態・対話行為・施設DBを対応させた中国語データセットである。</a:t>
-            </a:r>
-          </a:p>
-          <a:p>
-            <a:pPr marL="457200" indent="-355600">
-              <a:lnSpc>
-                <a:spcPts val="2439"/>
-              </a:lnSpc>
-              <a:spcAft>
-                <a:spcPts val="700"/>
-              </a:spcAft>
-              <a:buSzPct val="64878"/>
-              <a:buFont typeface="Noto Sans CJK JP"/>
-              <a:buChar char="●"/>
-              <a:defRPr sz="2050" b="0">
-                <a:solidFill>
-                  <a:srgbClr val="303437"/>
-                </a:solidFill>
-                <a:latin typeface="Noto Sans"/>
-              </a:defRPr>
-            </a:pPr>
-            <a:r>
-              <a:rPr sz="2050" b="0" lang="ja-JP" altLang="en-US">
-                <a:solidFill>
-                  <a:srgbClr val="303437"/>
-                </a:solidFill>
-                <a:latin typeface="Noto Sans"/>
-                <a:ea typeface="Noto Sans CJK JP"/>
-                <a:cs typeface="Noto Sans"/>
-              </a:rPr>
-              <a:t>一つの施設の回答から、周辺の施設や施設間の移動へと条件がつながる。施設間に依存関係のある旅行目標では、状態追跡の正解率が低かった。</a:t>
-            </a:r>
-          </a:p>
-          <a:p>
-            <a:pPr marL="457200" indent="-355600">
-              <a:lnSpc>
-                <a:spcPts val="2439"/>
-              </a:lnSpc>
-              <a:spcAft>
-                <a:spcPts val="0"/>
-              </a:spcAft>
-              <a:buSzPct val="64878"/>
-              <a:buFont typeface="Noto Sans CJK JP"/>
-              <a:buChar char="●"/>
-              <a:defRPr sz="2050" b="0">
-                <a:solidFill>
-                  <a:srgbClr val="303437"/>
-                </a:solidFill>
-                <a:latin typeface="Noto Sans"/>
-              </a:defRPr>
-            </a:pPr>
-            <a:r>
-              <a:rPr sz="2050" b="0" lang="ja-JP" altLang="en-US">
-                <a:solidFill>
-                  <a:srgbClr val="303437"/>
-                </a:solidFill>
-                <a:latin typeface="Noto Sans"/>
-                <a:ea typeface="Noto Sans CJK JP"/>
-                <a:cs typeface="Noto Sans"/>
-              </a:rPr>
-              <a:t>目標や状態の注釈は対話システムの各段階の評価に使える。収録された会話と応答は、履歴から次の発話を生成する課題にも使える。</a:t>
-            </a:r>
-          </a:p>
-        </p:txBody>
-      </p:sp>
-      <p:sp>
-        <p:nvSpPr>
-          <p:cNvPr id="4" name="Title 3"/>
+          <p:cNvPr id="3" name="Title 2"/>
           <p:cNvSpPr>
             <a:spLocks noGrp="1"/>
           </p:cNvSpPr>
@@ -20008,73 +19893,7 @@
                 <a:ea typeface="Noto Sans CJK JP"/>
                 <a:cs typeface="Noto Sans"/>
               </a:rPr>
-              <a:t>4. 入手と応答生成への利用</a:t>
-            </a:r>
-          </a:p>
-        </p:txBody>
-      </p:sp>
-      <p:sp>
-        <p:nvSpPr>
-          <p:cNvPr id="5" name="sources"/>
-          <p:cNvSpPr txBox="1"/>
-          <p:nvPr/>
-        </p:nvSpPr>
-        <p:spPr>
-          <a:xfrm>
-            <a:off x="502920" y="4699000"/>
-            <a:ext cx="8183879" cy="431800"/>
-          </a:xfrm>
-          <a:prstGeom prst="rect">
-            <a:avLst/>
-          </a:prstGeom>
-          <a:noFill/>
-        </p:spPr>
-        <p:txBody>
-          <a:bodyPr wrap="square" lIns="0" rIns="0" tIns="0" bIns="0">
-            <a:noAutofit/>
-          </a:bodyPr>
-          <a:lstStyle/>
-          <a:p>
-            <a:pPr algn="l">
-              <a:lnSpc>
-                <a:spcPts val="1200"/>
-              </a:lnSpc>
-              <a:spcBef>
-                <a:spcPts val="0"/>
-              </a:spcBef>
-              <a:spcAft>
-                <a:spcPts val="0"/>
-              </a:spcAft>
-              <a:buNone/>
-              <a:defRPr sz="810" b="0">
-                <a:solidFill>
-                  <a:srgbClr val="303437"/>
-                </a:solidFill>
-                <a:latin typeface="Noto Sans"/>
-              </a:defRPr>
-            </a:pPr>
-            <a:r>
-              <a:rPr sz="830">
-                <a:latin typeface="Noto Sans CJK JP"/>
-              </a:rPr>
-              <a:t>[1] Zhu et al. (2020). CrossWOZ: A Large-Scale Chinese Cross-Domain Task-Oriented Dialogue Dataset.</a:t>
-            </a:r>
-          </a:p>
-          <a:p>
-            <a:pPr>
-              <a:spcBef>
-                <a:spcPts val="0"/>
-              </a:spcBef>
-              <a:spcAft>
-                <a:spcPts val="0"/>
-              </a:spcAft>
-            </a:pPr>
-            <a:r>
-              <a:rPr sz="830">
-                <a:latin typeface="Noto Sans CJK JP"/>
-                <a:hlinkClick r:id="rId2"/>
-              </a:rPr>
-              <a:t>https://aclanthology.org/2020.tacl-1.19/</a:t>
+              <a:t>Appendix</a:t>
             </a:r>
           </a:p>
         </p:txBody>
@@ -20109,45 +19928,158 @@
         </p:nvSpPr>
         <p:spPr>
           <a:xfrm>
-            <a:off x="548640" y="2484835"/>
-            <a:ext cx="8046720" cy="585216"/>
+            <a:off x="468172" y="650138"/>
+            <a:ext cx="8206740" cy="616305"/>
           </a:xfrm>
         </p:spPr>
         <p:txBody>
-          <a:bodyPr wrap="square" lIns="0" rIns="0" tIns="0" bIns="0" anchor="ctr">
+          <a:bodyPr wrap="square" lIns="0" rIns="0" tIns="0" bIns="0">
             <a:noAutofit/>
           </a:bodyPr>
           <a:lstStyle/>
           <a:p>
-            <a:pPr algn="ctr">
+            <a:pPr algn="l">
               <a:lnSpc>
                 <a:spcPct val="110000"/>
               </a:lnSpc>
               <a:buNone/>
-              <a:defRPr sz="3600" b="0">
-                <a:solidFill>
-                  <a:srgbClr val="303437"/>
-                </a:solidFill>
-                <a:latin typeface="Noto Sans"/>
-              </a:defRPr>
-            </a:pPr>
-            <a:r>
-              <a:rPr sz="3600" b="1" lang="ja-JP" altLang="en-US">
-                <a:solidFill>
-                  <a:srgbClr val="303437"/>
-                </a:solidFill>
-                <a:latin typeface="Noto Sans"/>
-                <a:ea typeface="Noto Sans CJK JP"/>
-                <a:cs typeface="Noto Sans"/>
-              </a:rPr>
-              <a:t>Appendix</a:t>
+              <a:defRPr sz="2800" b="0">
+                <a:solidFill>
+                  <a:srgbClr val="303437"/>
+                </a:solidFill>
+                <a:latin typeface="Noto Sans"/>
+              </a:defRPr>
+            </a:pPr>
+            <a:r>
+              <a:rPr sz="2800" b="1" lang="ja-JP" altLang="en-US">
+                <a:solidFill>
+                  <a:srgbClr val="303437"/>
+                </a:solidFill>
+                <a:latin typeface="Noto Sans"/>
+                <a:ea typeface="Noto Sans CJK JP"/>
+                <a:cs typeface="Noto Sans"/>
+              </a:rPr>
+              <a:t/>
             </a:r>
           </a:p>
         </p:txBody>
       </p:sp>
       <p:sp>
         <p:nvSpPr>
-          <p:cNvPr id="3" name="Title 2"/>
+          <p:cNvPr id="3" name="Text Placeholder 2"/>
+          <p:cNvSpPr>
+            <a:spLocks noGrp="1"/>
+          </p:cNvSpPr>
+          <p:nvPr>
+            <p:ph type="body" idx="1"/>
+          </p:nvPr>
+        </p:nvSpPr>
+        <p:spPr>
+          <a:xfrm>
+            <a:off x="640080" y="1972511"/>
+            <a:ext cx="7863840" cy="1744980"/>
+          </a:xfrm>
+        </p:spPr>
+        <p:txBody>
+          <a:bodyPr lIns="0" rIns="0" tIns="0" bIns="0">
+            <a:noAutofit/>
+          </a:bodyPr>
+          <a:lstStyle/>
+          <a:p>
+            <a:pPr marL="457200" indent="-457200">
+              <a:lnSpc>
+                <a:spcPts val="3660"/>
+              </a:lnSpc>
+              <a:spcAft>
+                <a:spcPts val="1200"/>
+              </a:spcAft>
+              <a:buSzPct val="100000"/>
+              <a:buFont typeface="Noto Sans CJK JP"/>
+              <a:buAutoNum type="arabicPeriod" startAt="1"/>
+              <a:defRPr sz="3000" b="1">
+                <a:solidFill>
+                  <a:srgbClr val="303437"/>
+                </a:solidFill>
+                <a:latin typeface="Noto Sans"/>
+              </a:defRPr>
+            </a:pPr>
+            <a:r>
+              <a:rPr sz="3000" b="1" lang="ja-JP" altLang="en-US">
+                <a:solidFill>
+                  <a:srgbClr val="303437"/>
+                </a:solidFill>
+                <a:latin typeface="Noto Sans"/>
+                <a:ea typeface="Noto Sans CJK JP"/>
+                <a:cs typeface="Noto Sans"/>
+              </a:rPr>
+              <a:t>追加の対話</a:t>
+            </a:r>
+          </a:p>
+          <a:p>
+            <a:pPr marL="457200" indent="-457200">
+              <a:lnSpc>
+                <a:spcPts val="3660"/>
+              </a:lnSpc>
+              <a:spcAft>
+                <a:spcPts val="1200"/>
+              </a:spcAft>
+              <a:buSzPct val="100000"/>
+              <a:buFont typeface="Noto Sans CJK JP"/>
+              <a:buAutoNum type="arabicPeriod" startAt="2"/>
+              <a:defRPr sz="3000" b="1">
+                <a:solidFill>
+                  <a:srgbClr val="303437"/>
+                </a:solidFill>
+                <a:latin typeface="Noto Sans"/>
+              </a:defRPr>
+            </a:pPr>
+            <a:r>
+              <a:rPr sz="3000" b="1" lang="ja-JP" altLang="en-US">
+                <a:solidFill>
+                  <a:srgbClr val="303437"/>
+                </a:solidFill>
+                <a:latin typeface="Noto Sans"/>
+                <a:ea typeface="Noto Sans CJK JP"/>
+                <a:cs typeface="Noto Sans"/>
+              </a:rPr>
+              <a:t>データの読み方</a:t>
+            </a:r>
+          </a:p>
+          <a:p>
+            <a:pPr marL="457200" indent="-457200">
+              <a:lnSpc>
+                <a:spcPts val="3660"/>
+              </a:lnSpc>
+              <a:spcAft>
+                <a:spcPts val="0"/>
+              </a:spcAft>
+              <a:buSzPct val="100000"/>
+              <a:buFont typeface="Noto Sans CJK JP"/>
+              <a:buAutoNum type="arabicPeriod" startAt="3"/>
+              <a:defRPr sz="3000" b="1">
+                <a:solidFill>
+                  <a:srgbClr val="303437"/>
+                </a:solidFill>
+                <a:latin typeface="Noto Sans"/>
+              </a:defRPr>
+            </a:pPr>
+            <a:r>
+              <a:rPr sz="3000" b="1" lang="ja-JP" altLang="en-US">
+                <a:solidFill>
+                  <a:srgbClr val="303437"/>
+                </a:solidFill>
+                <a:latin typeface="Noto Sans"/>
+                <a:ea typeface="Noto Sans CJK JP"/>
+                <a:cs typeface="Noto Sans"/>
+              </a:rPr>
+              <a:t>研究と参考文献</a:t>
+            </a:r>
+          </a:p>
+        </p:txBody>
+      </p:sp>
+      <p:sp>
+        <p:nvSpPr>
+          <p:cNvPr id="4" name="Title 3"/>
           <p:cNvSpPr>
             <a:spLocks noGrp="1"/>
           </p:cNvSpPr>
@@ -20188,7 +20120,7 @@
                 <a:ea typeface="Noto Sans CJK JP"/>
                 <a:cs typeface="Noto Sans"/>
               </a:rPr>
-              <a:t>Appendix</a:t>
+              <a:t>Appendix: 目次</a:t>
             </a:r>
           </a:p>
         </p:txBody>
@@ -20223,233 +20155,6 @@
         </p:nvSpPr>
         <p:spPr>
           <a:xfrm>
-            <a:off x="468172" y="650138"/>
-            <a:ext cx="8206740" cy="616305"/>
-          </a:xfrm>
-        </p:spPr>
-        <p:txBody>
-          <a:bodyPr wrap="square" lIns="0" rIns="0" tIns="0" bIns="0">
-            <a:noAutofit/>
-          </a:bodyPr>
-          <a:lstStyle/>
-          <a:p>
-            <a:pPr algn="l">
-              <a:lnSpc>
-                <a:spcPct val="110000"/>
-              </a:lnSpc>
-              <a:buNone/>
-              <a:defRPr sz="2800" b="0">
-                <a:solidFill>
-                  <a:srgbClr val="303437"/>
-                </a:solidFill>
-                <a:latin typeface="Noto Sans"/>
-              </a:defRPr>
-            </a:pPr>
-            <a:r>
-              <a:rPr sz="2800" b="1" lang="ja-JP" altLang="en-US">
-                <a:solidFill>
-                  <a:srgbClr val="303437"/>
-                </a:solidFill>
-                <a:latin typeface="Noto Sans"/>
-                <a:ea typeface="Noto Sans CJK JP"/>
-                <a:cs typeface="Noto Sans"/>
-              </a:rPr>
-              <a:t/>
-            </a:r>
-          </a:p>
-        </p:txBody>
-      </p:sp>
-      <p:sp>
-        <p:nvSpPr>
-          <p:cNvPr id="3" name="Text Placeholder 2"/>
-          <p:cNvSpPr>
-            <a:spLocks noGrp="1"/>
-          </p:cNvSpPr>
-          <p:nvPr>
-            <p:ph type="body" idx="1"/>
-          </p:nvPr>
-        </p:nvSpPr>
-        <p:spPr>
-          <a:xfrm>
-            <a:off x="640080" y="1972511"/>
-            <a:ext cx="7863840" cy="1744980"/>
-          </a:xfrm>
-        </p:spPr>
-        <p:txBody>
-          <a:bodyPr lIns="0" rIns="0" tIns="0" bIns="0">
-            <a:noAutofit/>
-          </a:bodyPr>
-          <a:lstStyle/>
-          <a:p>
-            <a:pPr marL="457200" indent="-457200">
-              <a:lnSpc>
-                <a:spcPts val="3660"/>
-              </a:lnSpc>
-              <a:spcAft>
-                <a:spcPts val="1200"/>
-              </a:spcAft>
-              <a:buSzPct val="100000"/>
-              <a:buFont typeface="Noto Sans CJK JP"/>
-              <a:buAutoNum type="arabicPeriod" startAt="1"/>
-              <a:defRPr sz="3000" b="1">
-                <a:solidFill>
-                  <a:srgbClr val="303437"/>
-                </a:solidFill>
-                <a:latin typeface="Noto Sans"/>
-              </a:defRPr>
-            </a:pPr>
-            <a:r>
-              <a:rPr sz="3000" b="1" lang="ja-JP" altLang="en-US">
-                <a:solidFill>
-                  <a:srgbClr val="303437"/>
-                </a:solidFill>
-                <a:latin typeface="Noto Sans"/>
-                <a:ea typeface="Noto Sans CJK JP"/>
-                <a:cs typeface="Noto Sans"/>
-              </a:rPr>
-              <a:t>追加の対話</a:t>
-            </a:r>
-          </a:p>
-          <a:p>
-            <a:pPr marL="457200" indent="-457200">
-              <a:lnSpc>
-                <a:spcPts val="3660"/>
-              </a:lnSpc>
-              <a:spcAft>
-                <a:spcPts val="1200"/>
-              </a:spcAft>
-              <a:buSzPct val="100000"/>
-              <a:buFont typeface="Noto Sans CJK JP"/>
-              <a:buAutoNum type="arabicPeriod" startAt="2"/>
-              <a:defRPr sz="3000" b="1">
-                <a:solidFill>
-                  <a:srgbClr val="303437"/>
-                </a:solidFill>
-                <a:latin typeface="Noto Sans"/>
-              </a:defRPr>
-            </a:pPr>
-            <a:r>
-              <a:rPr sz="3000" b="1" lang="ja-JP" altLang="en-US">
-                <a:solidFill>
-                  <a:srgbClr val="303437"/>
-                </a:solidFill>
-                <a:latin typeface="Noto Sans"/>
-                <a:ea typeface="Noto Sans CJK JP"/>
-                <a:cs typeface="Noto Sans"/>
-              </a:rPr>
-              <a:t>データの読み方</a:t>
-            </a:r>
-          </a:p>
-          <a:p>
-            <a:pPr marL="457200" indent="-457200">
-              <a:lnSpc>
-                <a:spcPts val="3660"/>
-              </a:lnSpc>
-              <a:spcAft>
-                <a:spcPts val="0"/>
-              </a:spcAft>
-              <a:buSzPct val="100000"/>
-              <a:buFont typeface="Noto Sans CJK JP"/>
-              <a:buAutoNum type="arabicPeriod" startAt="3"/>
-              <a:defRPr sz="3000" b="1">
-                <a:solidFill>
-                  <a:srgbClr val="303437"/>
-                </a:solidFill>
-                <a:latin typeface="Noto Sans"/>
-              </a:defRPr>
-            </a:pPr>
-            <a:r>
-              <a:rPr sz="3000" b="1" lang="ja-JP" altLang="en-US">
-                <a:solidFill>
-                  <a:srgbClr val="303437"/>
-                </a:solidFill>
-                <a:latin typeface="Noto Sans"/>
-                <a:ea typeface="Noto Sans CJK JP"/>
-                <a:cs typeface="Noto Sans"/>
-              </a:rPr>
-              <a:t>研究と参考文献</a:t>
-            </a:r>
-          </a:p>
-        </p:txBody>
-      </p:sp>
-      <p:sp>
-        <p:nvSpPr>
-          <p:cNvPr id="4" name="Title 3"/>
-          <p:cNvSpPr>
-            <a:spLocks noGrp="1"/>
-          </p:cNvSpPr>
-          <p:nvPr>
-            <p:ph type="title" idx="2"/>
-          </p:nvPr>
-        </p:nvSpPr>
-        <p:spPr>
-          <a:xfrm>
-            <a:off x="75895" y="0"/>
-            <a:ext cx="8115300" cy="480060"/>
-          </a:xfrm>
-        </p:spPr>
-        <p:txBody>
-          <a:bodyPr wrap="square" lIns="0" rIns="0" tIns="0" bIns="0" anchor="ctr">
-            <a:noAutofit/>
-          </a:bodyPr>
-          <a:lstStyle/>
-          <a:p>
-            <a:pPr algn="l">
-              <a:lnSpc>
-                <a:spcPct val="110000"/>
-              </a:lnSpc>
-              <a:buNone/>
-              <a:defRPr sz="1400" b="0">
-                <a:solidFill>
-                  <a:srgbClr val="303437"/>
-                </a:solidFill>
-                <a:latin typeface="Noto Sans"/>
-              </a:defRPr>
-            </a:pPr>
-            <a:r>
-              <a:rPr sz="1400" b="1" lang="ja-JP" altLang="en-US">
-                <a:solidFill>
-                  <a:srgbClr val="FFFEF8"/>
-                </a:solidFill>
-                <a:latin typeface="Noto Sans"/>
-                <a:ea typeface="Noto Sans CJK JP"/>
-                <a:cs typeface="Noto Sans"/>
-              </a:rPr>
-              <a:t>Appendix: 目次</a:t>
-            </a:r>
-          </a:p>
-        </p:txBody>
-      </p:sp>
-    </p:spTree>
-  </p:cSld>
-  <p:clrMapOvr>
-    <a:masterClrMapping/>
-  </p:clrMapOvr>
-</p:sld>
-</file>
-
-<file path=ppt/slides/slide37.xml><?xml version="1.0" encoding="utf-8"?>
-<p:sld xmlns:a="http://schemas.openxmlformats.org/drawingml/2006/main" xmlns:p="http://schemas.openxmlformats.org/presentationml/2006/main" xmlns:r="http://schemas.openxmlformats.org/officeDocument/2006/relationships">
-  <p:cSld>
-    <p:spTree>
-      <p:nvGrpSpPr>
-        <p:cNvPr id="1" name=""/>
-        <p:cNvGrpSpPr/>
-        <p:nvPr/>
-      </p:nvGrpSpPr>
-      <p:grpSpPr/>
-      <p:sp>
-        <p:nvSpPr>
-          <p:cNvPr id="2" name="Title 1"/>
-          <p:cNvSpPr>
-            <a:spLocks noGrp="1"/>
-          </p:cNvSpPr>
-          <p:nvPr>
-            <p:ph type="title"/>
-          </p:nvPr>
-        </p:nvSpPr>
-        <p:spPr>
-          <a:xfrm>
             <a:off x="548640" y="2506875"/>
             <a:ext cx="8046720" cy="585216"/>
           </a:xfrm>
@@ -20542,7 +20247,7 @@
 </p:sld>
 </file>
 
-<file path=ppt/slides/slide38.xml><?xml version="1.0" encoding="utf-8"?>
+<file path=ppt/slides/slide37.xml><?xml version="1.0" encoding="utf-8"?>
 <p:sld xmlns:a="http://schemas.openxmlformats.org/drawingml/2006/main" xmlns:p="http://schemas.openxmlformats.org/presentationml/2006/main" xmlns:r="http://schemas.openxmlformats.org/officeDocument/2006/relationships">
   <p:cSld>
     <p:spTree>
@@ -21264,7 +20969,7 @@
 </p:sld>
 </file>
 
-<file path=ppt/slides/slide39.xml><?xml version="1.0" encoding="utf-8"?>
+<file path=ppt/slides/slide38.xml><?xml version="1.0" encoding="utf-8"?>
 <p:sld xmlns:a="http://schemas.openxmlformats.org/drawingml/2006/main" xmlns:p="http://schemas.openxmlformats.org/presentationml/2006/main" xmlns:r="http://schemas.openxmlformats.org/officeDocument/2006/relationships">
   <p:cSld>
     <p:spTree>
@@ -21986,121 +21691,7 @@
 </p:sld>
 </file>
 
-<file path=ppt/slides/slide4.xml><?xml version="1.0" encoding="utf-8"?>
-<p:sld xmlns:a="http://schemas.openxmlformats.org/drawingml/2006/main" xmlns:p="http://schemas.openxmlformats.org/presentationml/2006/main" xmlns:r="http://schemas.openxmlformats.org/officeDocument/2006/relationships">
-  <p:cSld>
-    <p:spTree>
-      <p:nvGrpSpPr>
-        <p:cNvPr id="1" name=""/>
-        <p:cNvGrpSpPr/>
-        <p:nvPr/>
-      </p:nvGrpSpPr>
-      <p:grpSpPr/>
-      <p:sp>
-        <p:nvSpPr>
-          <p:cNvPr id="2" name="Title 1"/>
-          <p:cNvSpPr>
-            <a:spLocks noGrp="1"/>
-          </p:cNvSpPr>
-          <p:nvPr>
-            <p:ph type="title"/>
-          </p:nvPr>
-        </p:nvSpPr>
-        <p:spPr>
-          <a:xfrm>
-            <a:off x="548640" y="2506875"/>
-            <a:ext cx="8046720" cy="585216"/>
-          </a:xfrm>
-        </p:spPr>
-        <p:txBody>
-          <a:bodyPr wrap="square" lIns="0" rIns="0" tIns="0" bIns="0" anchor="ctr">
-            <a:noAutofit/>
-          </a:bodyPr>
-          <a:lstStyle/>
-          <a:p>
-            <a:pPr algn="ctr">
-              <a:lnSpc>
-                <a:spcPct val="110000"/>
-              </a:lnSpc>
-              <a:buNone/>
-              <a:defRPr sz="3600" b="0">
-                <a:solidFill>
-                  <a:srgbClr val="303437"/>
-                </a:solidFill>
-                <a:latin typeface="Noto Sans"/>
-              </a:defRPr>
-            </a:pPr>
-            <a:r>
-              <a:rPr sz="3600" b="1" lang="ja-JP" altLang="en-US">
-                <a:solidFill>
-                  <a:srgbClr val="303437"/>
-                </a:solidFill>
-                <a:latin typeface="Noto Sans"/>
-                <a:ea typeface="Noto Sans CJK JP"/>
-                <a:cs typeface="Noto Sans"/>
-              </a:rPr>
-              <a:t>1. 旅行相談の対話と応答</a:t>
-            </a:r>
-          </a:p>
-        </p:txBody>
-      </p:sp>
-      <p:sp>
-        <p:nvSpPr>
-          <p:cNvPr id="3" name="Title 2"/>
-          <p:cNvSpPr>
-            <a:spLocks noGrp="1"/>
-          </p:cNvSpPr>
-          <p:nvPr>
-            <p:ph type="title" idx="2"/>
-          </p:nvPr>
-        </p:nvSpPr>
-        <p:spPr>
-          <a:xfrm>
-            <a:off x="75895" y="0"/>
-            <a:ext cx="8115300" cy="480060"/>
-          </a:xfrm>
-        </p:spPr>
-        <p:txBody>
-          <a:bodyPr wrap="square" lIns="0" rIns="0" tIns="0" bIns="0" anchor="ctr">
-            <a:noAutofit/>
-          </a:bodyPr>
-          <a:lstStyle/>
-          <a:p>
-            <a:pPr algn="l">
-              <a:lnSpc>
-                <a:spcPct val="110000"/>
-              </a:lnSpc>
-              <a:buNone/>
-              <a:defRPr sz="1400" b="0">
-                <a:solidFill>
-                  <a:srgbClr val="303437"/>
-                </a:solidFill>
-                <a:latin typeface="Noto Sans"/>
-              </a:defRPr>
-            </a:pPr>
-            <a:r>
-              <a:rPr sz="1400" b="1" lang="ja-JP" altLang="en-US">
-                <a:solidFill>
-                  <a:srgbClr val="FFFEF8"/>
-                </a:solidFill>
-                <a:latin typeface="Noto Sans"/>
-                <a:ea typeface="Noto Sans CJK JP"/>
-                <a:cs typeface="Noto Sans"/>
-              </a:rPr>
-              <a:t>1. 旅行相談の対話と応答</a:t>
-            </a:r>
-          </a:p>
-        </p:txBody>
-      </p:sp>
-    </p:spTree>
-  </p:cSld>
-  <p:clrMapOvr>
-    <a:masterClrMapping/>
-  </p:clrMapOvr>
-</p:sld>
-</file>
-
-<file path=ppt/slides/slide40.xml><?xml version="1.0" encoding="utf-8"?>
+<file path=ppt/slides/slide39.xml><?xml version="1.0" encoding="utf-8"?>
 <p:sld xmlns:a="http://schemas.openxmlformats.org/drawingml/2006/main" xmlns:p="http://schemas.openxmlformats.org/presentationml/2006/main" xmlns:r="http://schemas.openxmlformats.org/officeDocument/2006/relationships">
   <p:cSld>
     <p:spTree>
@@ -22822,7 +22413,121 @@
 </p:sld>
 </file>
 
-<file path=ppt/slides/slide41.xml><?xml version="1.0" encoding="utf-8"?>
+<file path=ppt/slides/slide4.xml><?xml version="1.0" encoding="utf-8"?>
+<p:sld xmlns:a="http://schemas.openxmlformats.org/drawingml/2006/main" xmlns:p="http://schemas.openxmlformats.org/presentationml/2006/main" xmlns:r="http://schemas.openxmlformats.org/officeDocument/2006/relationships">
+  <p:cSld>
+    <p:spTree>
+      <p:nvGrpSpPr>
+        <p:cNvPr id="1" name=""/>
+        <p:cNvGrpSpPr/>
+        <p:nvPr/>
+      </p:nvGrpSpPr>
+      <p:grpSpPr/>
+      <p:sp>
+        <p:nvSpPr>
+          <p:cNvPr id="2" name="Title 1"/>
+          <p:cNvSpPr>
+            <a:spLocks noGrp="1"/>
+          </p:cNvSpPr>
+          <p:nvPr>
+            <p:ph type="title"/>
+          </p:nvPr>
+        </p:nvSpPr>
+        <p:spPr>
+          <a:xfrm>
+            <a:off x="548640" y="2506875"/>
+            <a:ext cx="8046720" cy="585216"/>
+          </a:xfrm>
+        </p:spPr>
+        <p:txBody>
+          <a:bodyPr wrap="square" lIns="0" rIns="0" tIns="0" bIns="0" anchor="ctr">
+            <a:noAutofit/>
+          </a:bodyPr>
+          <a:lstStyle/>
+          <a:p>
+            <a:pPr algn="ctr">
+              <a:lnSpc>
+                <a:spcPct val="110000"/>
+              </a:lnSpc>
+              <a:buNone/>
+              <a:defRPr sz="3600" b="0">
+                <a:solidFill>
+                  <a:srgbClr val="303437"/>
+                </a:solidFill>
+                <a:latin typeface="Noto Sans"/>
+              </a:defRPr>
+            </a:pPr>
+            <a:r>
+              <a:rPr sz="3600" b="1" lang="ja-JP" altLang="en-US">
+                <a:solidFill>
+                  <a:srgbClr val="303437"/>
+                </a:solidFill>
+                <a:latin typeface="Noto Sans"/>
+                <a:ea typeface="Noto Sans CJK JP"/>
+                <a:cs typeface="Noto Sans"/>
+              </a:rPr>
+              <a:t>1. 旅行相談の対話と応答</a:t>
+            </a:r>
+          </a:p>
+        </p:txBody>
+      </p:sp>
+      <p:sp>
+        <p:nvSpPr>
+          <p:cNvPr id="3" name="Title 2"/>
+          <p:cNvSpPr>
+            <a:spLocks noGrp="1"/>
+          </p:cNvSpPr>
+          <p:nvPr>
+            <p:ph type="title" idx="2"/>
+          </p:nvPr>
+        </p:nvSpPr>
+        <p:spPr>
+          <a:xfrm>
+            <a:off x="75895" y="0"/>
+            <a:ext cx="8115300" cy="480060"/>
+          </a:xfrm>
+        </p:spPr>
+        <p:txBody>
+          <a:bodyPr wrap="square" lIns="0" rIns="0" tIns="0" bIns="0" anchor="ctr">
+            <a:noAutofit/>
+          </a:bodyPr>
+          <a:lstStyle/>
+          <a:p>
+            <a:pPr algn="l">
+              <a:lnSpc>
+                <a:spcPct val="110000"/>
+              </a:lnSpc>
+              <a:buNone/>
+              <a:defRPr sz="1400" b="0">
+                <a:solidFill>
+                  <a:srgbClr val="303437"/>
+                </a:solidFill>
+                <a:latin typeface="Noto Sans"/>
+              </a:defRPr>
+            </a:pPr>
+            <a:r>
+              <a:rPr sz="1400" b="1" lang="ja-JP" altLang="en-US">
+                <a:solidFill>
+                  <a:srgbClr val="FFFEF8"/>
+                </a:solidFill>
+                <a:latin typeface="Noto Sans"/>
+                <a:ea typeface="Noto Sans CJK JP"/>
+                <a:cs typeface="Noto Sans"/>
+              </a:rPr>
+              <a:t>1. 旅行相談の対話と応答</a:t>
+            </a:r>
+          </a:p>
+        </p:txBody>
+      </p:sp>
+    </p:spTree>
+  </p:cSld>
+  <p:clrMapOvr>
+    <a:masterClrMapping/>
+  </p:clrMapOvr>
+</p:sld>
+</file>
+
+<file path=ppt/slides/slide40.xml><?xml version="1.0" encoding="utf-8"?>
 <p:sld xmlns:a="http://schemas.openxmlformats.org/drawingml/2006/main" xmlns:p="http://schemas.openxmlformats.org/presentationml/2006/main" xmlns:r="http://schemas.openxmlformats.org/officeDocument/2006/relationships">
   <p:cSld>
     <p:spTree>
@@ -23300,7 +23005,7 @@
 </p:sld>
 </file>
 
-<file path=ppt/slides/slide42.xml><?xml version="1.0" encoding="utf-8"?>
+<file path=ppt/slides/slide41.xml><?xml version="1.0" encoding="utf-8"?>
 <p:sld xmlns:a="http://schemas.openxmlformats.org/drawingml/2006/main" xmlns:p="http://schemas.openxmlformats.org/presentationml/2006/main" xmlns:r="http://schemas.openxmlformats.org/officeDocument/2006/relationships">
   <p:cSld>
     <p:spTree>
@@ -23778,7 +23483,7 @@
 </p:sld>
 </file>
 
-<file path=ppt/slides/slide43.xml><?xml version="1.0" encoding="utf-8"?>
+<file path=ppt/slides/slide42.xml><?xml version="1.0" encoding="utf-8"?>
 <p:sld xmlns:a="http://schemas.openxmlformats.org/drawingml/2006/main" xmlns:p="http://schemas.openxmlformats.org/presentationml/2006/main" xmlns:r="http://schemas.openxmlformats.org/officeDocument/2006/relationships">
   <p:cSld>
     <p:spTree>
@@ -24376,7 +24081,7 @@
 </p:sld>
 </file>
 
-<file path=ppt/slides/slide44.xml><?xml version="1.0" encoding="utf-8"?>
+<file path=ppt/slides/slide43.xml><?xml version="1.0" encoding="utf-8"?>
 <p:sld xmlns:a="http://schemas.openxmlformats.org/drawingml/2006/main" xmlns:p="http://schemas.openxmlformats.org/presentationml/2006/main" xmlns:r="http://schemas.openxmlformats.org/officeDocument/2006/relationships">
   <p:cSld>
     <p:spTree>
@@ -24974,7 +24679,7 @@
 </p:sld>
 </file>
 
-<file path=ppt/slides/slide45.xml><?xml version="1.0" encoding="utf-8"?>
+<file path=ppt/slides/slide44.xml><?xml version="1.0" encoding="utf-8"?>
 <p:sld xmlns:a="http://schemas.openxmlformats.org/drawingml/2006/main" xmlns:p="http://schemas.openxmlformats.org/presentationml/2006/main" xmlns:r="http://schemas.openxmlformats.org/officeDocument/2006/relationships">
   <p:cSld>
     <p:spTree>
@@ -25534,7 +25239,7 @@
 </p:sld>
 </file>
 
-<file path=ppt/slides/slide46.xml><?xml version="1.0" encoding="utf-8"?>
+<file path=ppt/slides/slide45.xml><?xml version="1.0" encoding="utf-8"?>
 <p:sld xmlns:a="http://schemas.openxmlformats.org/drawingml/2006/main" xmlns:p="http://schemas.openxmlformats.org/presentationml/2006/main" xmlns:r="http://schemas.openxmlformats.org/officeDocument/2006/relationships">
   <p:cSld>
     <p:spTree>
@@ -26094,7 +25799,7 @@
 </p:sld>
 </file>
 
-<file path=ppt/slides/slide47.xml><?xml version="1.0" encoding="utf-8"?>
+<file path=ppt/slides/slide46.xml><?xml version="1.0" encoding="utf-8"?>
 <p:sld xmlns:a="http://schemas.openxmlformats.org/drawingml/2006/main" xmlns:p="http://schemas.openxmlformats.org/presentationml/2006/main" xmlns:r="http://schemas.openxmlformats.org/officeDocument/2006/relationships">
   <p:cSld>
     <p:spTree>
@@ -26747,7 +26452,7 @@
 </p:sld>
 </file>
 
-<file path=ppt/slides/slide48.xml><?xml version="1.0" encoding="utf-8"?>
+<file path=ppt/slides/slide47.xml><?xml version="1.0" encoding="utf-8"?>
 <p:sld xmlns:a="http://schemas.openxmlformats.org/drawingml/2006/main" xmlns:p="http://schemas.openxmlformats.org/presentationml/2006/main" xmlns:r="http://schemas.openxmlformats.org/officeDocument/2006/relationships">
   <p:cSld>
     <p:spTree>
@@ -27431,7 +27136,7 @@
 </p:sld>
 </file>
 
-<file path=ppt/slides/slide49.xml><?xml version="1.0" encoding="utf-8"?>
+<file path=ppt/slides/slide48.xml><?xml version="1.0" encoding="utf-8"?>
 <p:sld xmlns:a="http://schemas.openxmlformats.org/drawingml/2006/main" xmlns:p="http://schemas.openxmlformats.org/presentationml/2006/main" xmlns:r="http://schemas.openxmlformats.org/officeDocument/2006/relationships">
   <p:cSld>
     <p:spTree>
@@ -28115,300 +27820,7 @@
 </p:sld>
 </file>
 
-<file path=ppt/slides/slide5.xml><?xml version="1.0" encoding="utf-8"?>
-<p:sld xmlns:a="http://schemas.openxmlformats.org/drawingml/2006/main" xmlns:p="http://schemas.openxmlformats.org/presentationml/2006/main" xmlns:r="http://schemas.openxmlformats.org/officeDocument/2006/relationships">
-  <p:cSld>
-    <p:spTree>
-      <p:nvGrpSpPr>
-        <p:cNvPr id="1" name=""/>
-        <p:cNvGrpSpPr/>
-        <p:nvPr/>
-      </p:nvGrpSpPr>
-      <p:grpSpPr/>
-      <p:sp>
-        <p:nvSpPr>
-          <p:cNvPr id="2" name="Title 1"/>
-          <p:cNvSpPr>
-            <a:spLocks noGrp="1"/>
-          </p:cNvSpPr>
-          <p:nvPr>
-            <p:ph type="title"/>
-          </p:nvPr>
-        </p:nvSpPr>
-        <p:spPr>
-          <a:xfrm>
-            <a:off x="468172" y="650138"/>
-            <a:ext cx="8206740" cy="616305"/>
-          </a:xfrm>
-        </p:spPr>
-        <p:txBody>
-          <a:bodyPr wrap="square" lIns="0" rIns="0" tIns="0" bIns="0">
-            <a:noAutofit/>
-          </a:bodyPr>
-          <a:lstStyle/>
-          <a:p>
-            <a:pPr algn="l">
-              <a:lnSpc>
-                <a:spcPct val="110000"/>
-              </a:lnSpc>
-              <a:buNone/>
-              <a:defRPr sz="2800" b="0">
-                <a:solidFill>
-                  <a:srgbClr val="303437"/>
-                </a:solidFill>
-                <a:latin typeface="Noto Sans"/>
-              </a:defRPr>
-            </a:pPr>
-            <a:r>
-              <a:rPr sz="2800" b="1" lang="ja-JP" altLang="en-US">
-                <a:solidFill>
-                  <a:srgbClr val="303437"/>
-                </a:solidFill>
-                <a:latin typeface="Noto Sans"/>
-                <a:ea typeface="Noto Sans CJK JP"/>
-                <a:cs typeface="Noto Sans"/>
-              </a:rPr>
-              <a:t>旅行の相談を、複数の領域へつなぐ</a:t>
-            </a:r>
-          </a:p>
-        </p:txBody>
-      </p:sp>
-      <p:sp>
-        <p:nvSpPr>
-          <p:cNvPr id="3" name="Text Placeholder 2"/>
-          <p:cNvSpPr>
-            <a:spLocks noGrp="1"/>
-          </p:cNvSpPr>
-          <p:nvPr>
-            <p:ph type="body" idx="1"/>
-          </p:nvPr>
-        </p:nvSpPr>
-        <p:spPr>
-          <a:xfrm>
-            <a:off x="594360" y="1463040"/>
-            <a:ext cx="7955279" cy="3044952"/>
-          </a:xfrm>
-        </p:spPr>
-        <p:txBody>
-          <a:bodyPr wrap="square" tIns="91440" bIns="91440">
-            <a:noAutofit/>
-          </a:bodyPr>
-          <a:lstStyle/>
-          <a:p>
-            <a:pPr marL="457200" indent="-355600">
-              <a:lnSpc>
-                <a:spcPts val="2499"/>
-              </a:lnSpc>
-              <a:spcAft>
-                <a:spcPts val="700"/>
-              </a:spcAft>
-              <a:buSzPct val="63333"/>
-              <a:buFont typeface="Noto Sans CJK JP"/>
-              <a:buChar char="●"/>
-              <a:defRPr sz="2100" b="0">
-                <a:solidFill>
-                  <a:srgbClr val="303437"/>
-                </a:solidFill>
-                <a:latin typeface="Noto Sans"/>
-              </a:defRPr>
-            </a:pPr>
-            <a:r>
-              <a:rPr sz="2100" b="0" lang="ja-JP" altLang="en-US">
-                <a:solidFill>
-                  <a:srgbClr val="303437"/>
-                </a:solidFill>
-                <a:latin typeface="Noto Sans"/>
-                <a:ea typeface="Noto Sans CJK JP"/>
-                <a:cs typeface="Noto Sans"/>
-              </a:rPr>
-              <a:t>CrossWOZは、北京の旅行情報を尋ねる中国語のタスク指向対話を集めたデータセット。ホテル、レストラン、観光地、地下鉄、タクシーの5領域を扱う。</a:t>
-            </a:r>
-          </a:p>
-          <a:p>
-            <a:pPr marL="457200" indent="-355600">
-              <a:lnSpc>
-                <a:spcPts val="2499"/>
-              </a:lnSpc>
-              <a:spcAft>
-                <a:spcPts val="700"/>
-              </a:spcAft>
-              <a:buSzPct val="63333"/>
-              <a:buFont typeface="Noto Sans CJK JP"/>
-              <a:buChar char="●"/>
-              <a:defRPr sz="2100" b="0">
-                <a:solidFill>
-                  <a:srgbClr val="303437"/>
-                </a:solidFill>
-                <a:latin typeface="Noto Sans"/>
-              </a:defRPr>
-            </a:pPr>
-            <a:r>
-              <a:rPr sz="2100" b="0" lang="ja-JP" altLang="en-US">
-                <a:solidFill>
-                  <a:srgbClr val="303437"/>
-                </a:solidFill>
-                <a:latin typeface="Noto Sans"/>
-                <a:ea typeface="Noto Sans CJK JP"/>
-                <a:cs typeface="Noto Sans"/>
-              </a:rPr>
-              <a:t>旅行者役と案内役の人間が会話し、施設の条件や、選んだ施設の周辺、施設間の移動を順に決める。</a:t>
-            </a:r>
-          </a:p>
-          <a:p>
-            <a:pPr marL="457200" indent="-355600">
-              <a:lnSpc>
-                <a:spcPts val="2499"/>
-              </a:lnSpc>
-              <a:spcAft>
-                <a:spcPts val="0"/>
-              </a:spcAft>
-              <a:buSzPct val="63333"/>
-              <a:buFont typeface="Noto Sans CJK JP"/>
-              <a:buChar char="●"/>
-              <a:defRPr sz="2100" b="0">
-                <a:solidFill>
-                  <a:srgbClr val="303437"/>
-                </a:solidFill>
-                <a:latin typeface="Noto Sans"/>
-              </a:defRPr>
-            </a:pPr>
-            <a:r>
-              <a:rPr sz="2100" b="0" lang="ja-JP" altLang="en-US">
-                <a:solidFill>
-                  <a:srgbClr val="303437"/>
-                </a:solidFill>
-                <a:latin typeface="Noto Sans"/>
-                <a:ea typeface="Noto Sans CJK JP"/>
-                <a:cs typeface="Noto Sans"/>
-              </a:rPr>
-              <a:t>発話だけでなく、達成したい目標、会話中の状態、伝えた内容の注釈、検索用DBを持つ。</a:t>
-            </a:r>
-          </a:p>
-        </p:txBody>
-      </p:sp>
-      <p:sp>
-        <p:nvSpPr>
-          <p:cNvPr id="4" name="Title 3"/>
-          <p:cNvSpPr>
-            <a:spLocks noGrp="1"/>
-          </p:cNvSpPr>
-          <p:nvPr>
-            <p:ph type="title" idx="2"/>
-          </p:nvPr>
-        </p:nvSpPr>
-        <p:spPr>
-          <a:xfrm>
-            <a:off x="75895" y="0"/>
-            <a:ext cx="8115300" cy="480060"/>
-          </a:xfrm>
-        </p:spPr>
-        <p:txBody>
-          <a:bodyPr wrap="square" lIns="0" rIns="0" tIns="0" bIns="0" anchor="ctr">
-            <a:noAutofit/>
-          </a:bodyPr>
-          <a:lstStyle/>
-          <a:p>
-            <a:pPr algn="l">
-              <a:lnSpc>
-                <a:spcPct val="110000"/>
-              </a:lnSpc>
-              <a:buNone/>
-              <a:defRPr sz="1400" b="0">
-                <a:solidFill>
-                  <a:srgbClr val="303437"/>
-                </a:solidFill>
-                <a:latin typeface="Noto Sans"/>
-              </a:defRPr>
-            </a:pPr>
-            <a:r>
-              <a:rPr sz="1400" b="1" lang="ja-JP" altLang="en-US">
-                <a:solidFill>
-                  <a:srgbClr val="FFFEF8"/>
-                </a:solidFill>
-                <a:latin typeface="Noto Sans"/>
-                <a:ea typeface="Noto Sans CJK JP"/>
-                <a:cs typeface="Noto Sans"/>
-              </a:rPr>
-              <a:t>1. 旅行相談の対話と応答</a:t>
-            </a:r>
-          </a:p>
-        </p:txBody>
-      </p:sp>
-      <p:sp>
-        <p:nvSpPr>
-          <p:cNvPr id="5" name="sources"/>
-          <p:cNvSpPr txBox="1"/>
-          <p:nvPr/>
-        </p:nvSpPr>
-        <p:spPr>
-          <a:xfrm>
-            <a:off x="502920" y="4699000"/>
-            <a:ext cx="8183879" cy="431800"/>
-          </a:xfrm>
-          <a:prstGeom prst="rect">
-            <a:avLst/>
-          </a:prstGeom>
-          <a:noFill/>
-        </p:spPr>
-        <p:txBody>
-          <a:bodyPr wrap="square" lIns="0" rIns="0" tIns="0" bIns="0">
-            <a:noAutofit/>
-          </a:bodyPr>
-          <a:lstStyle/>
-          <a:p>
-            <a:pPr algn="l">
-              <a:lnSpc>
-                <a:spcPts val="1200"/>
-              </a:lnSpc>
-              <a:spcBef>
-                <a:spcPts val="0"/>
-              </a:spcBef>
-              <a:spcAft>
-                <a:spcPts val="0"/>
-              </a:spcAft>
-              <a:buNone/>
-              <a:defRPr sz="810" b="0">
-                <a:solidFill>
-                  <a:srgbClr val="303437"/>
-                </a:solidFill>
-                <a:latin typeface="Noto Sans"/>
-              </a:defRPr>
-            </a:pPr>
-            <a:r>
-              <a:rPr sz="830">
-                <a:latin typeface="Noto Sans CJK JP"/>
-              </a:rPr>
-              <a:t>[1] Zhu et al. (2020). CrossWOZ: A Large-Scale Chinese Cross-Domain Task-Oriented Dialogue Dataset.</a:t>
-            </a:r>
-          </a:p>
-          <a:p>
-            <a:pPr>
-              <a:spcBef>
-                <a:spcPts val="0"/>
-              </a:spcBef>
-              <a:spcAft>
-                <a:spcPts val="0"/>
-              </a:spcAft>
-            </a:pPr>
-            <a:r>
-              <a:rPr sz="830">
-                <a:latin typeface="Noto Sans CJK JP"/>
-                <a:hlinkClick r:id="rId2"/>
-              </a:rPr>
-              <a:t>https://aclanthology.org/2020.tacl-1.19/</a:t>
-            </a:r>
-          </a:p>
-        </p:txBody>
-      </p:sp>
-    </p:spTree>
-  </p:cSld>
-  <p:clrMapOvr>
-    <a:masterClrMapping/>
-  </p:clrMapOvr>
-</p:sld>
-</file>
-
-<file path=ppt/slides/slide50.xml><?xml version="1.0" encoding="utf-8"?>
+<file path=ppt/slides/slide49.xml><?xml version="1.0" encoding="utf-8"?>
 <p:sld xmlns:a="http://schemas.openxmlformats.org/drawingml/2006/main" xmlns:p="http://schemas.openxmlformats.org/presentationml/2006/main" xmlns:r="http://schemas.openxmlformats.org/officeDocument/2006/relationships">
   <p:cSld>
     <p:spTree>
@@ -29061,7 +28473,300 @@
 </p:sld>
 </file>
 
-<file path=ppt/slides/slide51.xml><?xml version="1.0" encoding="utf-8"?>
+<file path=ppt/slides/slide5.xml><?xml version="1.0" encoding="utf-8"?>
+<p:sld xmlns:a="http://schemas.openxmlformats.org/drawingml/2006/main" xmlns:p="http://schemas.openxmlformats.org/presentationml/2006/main" xmlns:r="http://schemas.openxmlformats.org/officeDocument/2006/relationships">
+  <p:cSld>
+    <p:spTree>
+      <p:nvGrpSpPr>
+        <p:cNvPr id="1" name=""/>
+        <p:cNvGrpSpPr/>
+        <p:nvPr/>
+      </p:nvGrpSpPr>
+      <p:grpSpPr/>
+      <p:sp>
+        <p:nvSpPr>
+          <p:cNvPr id="2" name="Title 1"/>
+          <p:cNvSpPr>
+            <a:spLocks noGrp="1"/>
+          </p:cNvSpPr>
+          <p:nvPr>
+            <p:ph type="title"/>
+          </p:nvPr>
+        </p:nvSpPr>
+        <p:spPr>
+          <a:xfrm>
+            <a:off x="468172" y="650138"/>
+            <a:ext cx="8206740" cy="616305"/>
+          </a:xfrm>
+        </p:spPr>
+        <p:txBody>
+          <a:bodyPr wrap="square" lIns="0" rIns="0" tIns="0" bIns="0">
+            <a:noAutofit/>
+          </a:bodyPr>
+          <a:lstStyle/>
+          <a:p>
+            <a:pPr algn="l">
+              <a:lnSpc>
+                <a:spcPct val="110000"/>
+              </a:lnSpc>
+              <a:buNone/>
+              <a:defRPr sz="2800" b="0">
+                <a:solidFill>
+                  <a:srgbClr val="303437"/>
+                </a:solidFill>
+                <a:latin typeface="Noto Sans"/>
+              </a:defRPr>
+            </a:pPr>
+            <a:r>
+              <a:rPr sz="2800" b="1" lang="ja-JP" altLang="en-US">
+                <a:solidFill>
+                  <a:srgbClr val="303437"/>
+                </a:solidFill>
+                <a:latin typeface="Noto Sans"/>
+                <a:ea typeface="Noto Sans CJK JP"/>
+                <a:cs typeface="Noto Sans"/>
+              </a:rPr>
+              <a:t>旅行の相談を、複数の領域へつなぐ</a:t>
+            </a:r>
+          </a:p>
+        </p:txBody>
+      </p:sp>
+      <p:sp>
+        <p:nvSpPr>
+          <p:cNvPr id="3" name="Text Placeholder 2"/>
+          <p:cNvSpPr>
+            <a:spLocks noGrp="1"/>
+          </p:cNvSpPr>
+          <p:nvPr>
+            <p:ph type="body" idx="1"/>
+          </p:nvPr>
+        </p:nvSpPr>
+        <p:spPr>
+          <a:xfrm>
+            <a:off x="594360" y="1463040"/>
+            <a:ext cx="7955279" cy="3044952"/>
+          </a:xfrm>
+        </p:spPr>
+        <p:txBody>
+          <a:bodyPr wrap="square" tIns="91440" bIns="91440">
+            <a:noAutofit/>
+          </a:bodyPr>
+          <a:lstStyle/>
+          <a:p>
+            <a:pPr marL="457200" indent="-355600">
+              <a:lnSpc>
+                <a:spcPts val="2499"/>
+              </a:lnSpc>
+              <a:spcAft>
+                <a:spcPts val="700"/>
+              </a:spcAft>
+              <a:buSzPct val="63333"/>
+              <a:buFont typeface="Noto Sans CJK JP"/>
+              <a:buChar char="●"/>
+              <a:defRPr sz="2100" b="0">
+                <a:solidFill>
+                  <a:srgbClr val="303437"/>
+                </a:solidFill>
+                <a:latin typeface="Noto Sans"/>
+              </a:defRPr>
+            </a:pPr>
+            <a:r>
+              <a:rPr sz="2100" b="0" lang="ja-JP" altLang="en-US">
+                <a:solidFill>
+                  <a:srgbClr val="303437"/>
+                </a:solidFill>
+                <a:latin typeface="Noto Sans"/>
+                <a:ea typeface="Noto Sans CJK JP"/>
+                <a:cs typeface="Noto Sans"/>
+              </a:rPr>
+              <a:t>CrossWOZは、北京の旅行情報を尋ねる中国語のタスク指向対話を集めたデータセット。ホテル、レストラン、観光地、地下鉄、タクシーの5領域を扱う。</a:t>
+            </a:r>
+          </a:p>
+          <a:p>
+            <a:pPr marL="457200" indent="-355600">
+              <a:lnSpc>
+                <a:spcPts val="2499"/>
+              </a:lnSpc>
+              <a:spcAft>
+                <a:spcPts val="700"/>
+              </a:spcAft>
+              <a:buSzPct val="63333"/>
+              <a:buFont typeface="Noto Sans CJK JP"/>
+              <a:buChar char="●"/>
+              <a:defRPr sz="2100" b="0">
+                <a:solidFill>
+                  <a:srgbClr val="303437"/>
+                </a:solidFill>
+                <a:latin typeface="Noto Sans"/>
+              </a:defRPr>
+            </a:pPr>
+            <a:r>
+              <a:rPr sz="2100" b="0" lang="ja-JP" altLang="en-US">
+                <a:solidFill>
+                  <a:srgbClr val="303437"/>
+                </a:solidFill>
+                <a:latin typeface="Noto Sans"/>
+                <a:ea typeface="Noto Sans CJK JP"/>
+                <a:cs typeface="Noto Sans"/>
+              </a:rPr>
+              <a:t>旅行者役と案内役の人間が会話し、施設の条件や、選んだ施設の周辺、施設間の移動を順に決める。</a:t>
+            </a:r>
+          </a:p>
+          <a:p>
+            <a:pPr marL="457200" indent="-355600">
+              <a:lnSpc>
+                <a:spcPts val="2499"/>
+              </a:lnSpc>
+              <a:spcAft>
+                <a:spcPts val="0"/>
+              </a:spcAft>
+              <a:buSzPct val="63333"/>
+              <a:buFont typeface="Noto Sans CJK JP"/>
+              <a:buChar char="●"/>
+              <a:defRPr sz="2100" b="0">
+                <a:solidFill>
+                  <a:srgbClr val="303437"/>
+                </a:solidFill>
+                <a:latin typeface="Noto Sans"/>
+              </a:defRPr>
+            </a:pPr>
+            <a:r>
+              <a:rPr sz="2100" b="0" lang="ja-JP" altLang="en-US">
+                <a:solidFill>
+                  <a:srgbClr val="303437"/>
+                </a:solidFill>
+                <a:latin typeface="Noto Sans"/>
+                <a:ea typeface="Noto Sans CJK JP"/>
+                <a:cs typeface="Noto Sans"/>
+              </a:rPr>
+              <a:t>発話だけでなく、達成したい目標、会話中の状態、伝えた内容の注釈、検索用DBを持つ。</a:t>
+            </a:r>
+          </a:p>
+        </p:txBody>
+      </p:sp>
+      <p:sp>
+        <p:nvSpPr>
+          <p:cNvPr id="4" name="Title 3"/>
+          <p:cNvSpPr>
+            <a:spLocks noGrp="1"/>
+          </p:cNvSpPr>
+          <p:nvPr>
+            <p:ph type="title" idx="2"/>
+          </p:nvPr>
+        </p:nvSpPr>
+        <p:spPr>
+          <a:xfrm>
+            <a:off x="75895" y="0"/>
+            <a:ext cx="8115300" cy="480060"/>
+          </a:xfrm>
+        </p:spPr>
+        <p:txBody>
+          <a:bodyPr wrap="square" lIns="0" rIns="0" tIns="0" bIns="0" anchor="ctr">
+            <a:noAutofit/>
+          </a:bodyPr>
+          <a:lstStyle/>
+          <a:p>
+            <a:pPr algn="l">
+              <a:lnSpc>
+                <a:spcPct val="110000"/>
+              </a:lnSpc>
+              <a:buNone/>
+              <a:defRPr sz="1400" b="0">
+                <a:solidFill>
+                  <a:srgbClr val="303437"/>
+                </a:solidFill>
+                <a:latin typeface="Noto Sans"/>
+              </a:defRPr>
+            </a:pPr>
+            <a:r>
+              <a:rPr sz="1400" b="1" lang="ja-JP" altLang="en-US">
+                <a:solidFill>
+                  <a:srgbClr val="FFFEF8"/>
+                </a:solidFill>
+                <a:latin typeface="Noto Sans"/>
+                <a:ea typeface="Noto Sans CJK JP"/>
+                <a:cs typeface="Noto Sans"/>
+              </a:rPr>
+              <a:t>1. 旅行相談の対話と応答</a:t>
+            </a:r>
+          </a:p>
+        </p:txBody>
+      </p:sp>
+      <p:sp>
+        <p:nvSpPr>
+          <p:cNvPr id="5" name="sources"/>
+          <p:cNvSpPr txBox="1"/>
+          <p:nvPr/>
+        </p:nvSpPr>
+        <p:spPr>
+          <a:xfrm>
+            <a:off x="502920" y="4699000"/>
+            <a:ext cx="8183879" cy="431800"/>
+          </a:xfrm>
+          <a:prstGeom prst="rect">
+            <a:avLst/>
+          </a:prstGeom>
+          <a:noFill/>
+        </p:spPr>
+        <p:txBody>
+          <a:bodyPr wrap="square" lIns="0" rIns="0" tIns="0" bIns="0">
+            <a:noAutofit/>
+          </a:bodyPr>
+          <a:lstStyle/>
+          <a:p>
+            <a:pPr algn="l">
+              <a:lnSpc>
+                <a:spcPts val="1200"/>
+              </a:lnSpc>
+              <a:spcBef>
+                <a:spcPts val="0"/>
+              </a:spcBef>
+              <a:spcAft>
+                <a:spcPts val="0"/>
+              </a:spcAft>
+              <a:buNone/>
+              <a:defRPr sz="810" b="0">
+                <a:solidFill>
+                  <a:srgbClr val="303437"/>
+                </a:solidFill>
+                <a:latin typeface="Noto Sans"/>
+              </a:defRPr>
+            </a:pPr>
+            <a:r>
+              <a:rPr sz="830">
+                <a:latin typeface="Noto Sans CJK JP"/>
+              </a:rPr>
+              <a:t>[1] Zhu et al. (2020). CrossWOZ: A Large-Scale Chinese Cross-Domain Task-Oriented Dialogue Dataset.</a:t>
+            </a:r>
+          </a:p>
+          <a:p>
+            <a:pPr>
+              <a:spcBef>
+                <a:spcPts val="0"/>
+              </a:spcBef>
+              <a:spcAft>
+                <a:spcPts val="0"/>
+              </a:spcAft>
+            </a:pPr>
+            <a:r>
+              <a:rPr sz="830">
+                <a:latin typeface="Noto Sans CJK JP"/>
+                <a:hlinkClick r:id="rId2"/>
+              </a:rPr>
+              <a:t>https://aclanthology.org/2020.tacl-1.19/</a:t>
+            </a:r>
+          </a:p>
+        </p:txBody>
+      </p:sp>
+    </p:spTree>
+  </p:cSld>
+  <p:clrMapOvr>
+    <a:masterClrMapping/>
+  </p:clrMapOvr>
+</p:sld>
+</file>
+
+<file path=ppt/slides/slide50.xml><?xml version="1.0" encoding="utf-8"?>
 <p:sld xmlns:a="http://schemas.openxmlformats.org/drawingml/2006/main" xmlns:p="http://schemas.openxmlformats.org/presentationml/2006/main" xmlns:r="http://schemas.openxmlformats.org/officeDocument/2006/relationships">
   <p:cSld>
     <p:spTree>
@@ -29714,7 +29419,7 @@
 </p:sld>
 </file>
 
-<file path=ppt/slides/slide52.xml><?xml version="1.0" encoding="utf-8"?>
+<file path=ppt/slides/slide51.xml><?xml version="1.0" encoding="utf-8"?>
 <p:sld xmlns:a="http://schemas.openxmlformats.org/drawingml/2006/main" xmlns:p="http://schemas.openxmlformats.org/presentationml/2006/main" xmlns:r="http://schemas.openxmlformats.org/officeDocument/2006/relationships">
   <p:cSld>
     <p:spTree>
@@ -30367,7 +30072,7 @@
 </p:sld>
 </file>
 
-<file path=ppt/slides/slide53.xml><?xml version="1.0" encoding="utf-8"?>
+<file path=ppt/slides/slide52.xml><?xml version="1.0" encoding="utf-8"?>
 <p:sld xmlns:a="http://schemas.openxmlformats.org/drawingml/2006/main" xmlns:p="http://schemas.openxmlformats.org/presentationml/2006/main" xmlns:r="http://schemas.openxmlformats.org/officeDocument/2006/relationships">
   <p:cSld>
     <p:spTree>
@@ -30481,7 +30186,7 @@
 </p:sld>
 </file>
 
-<file path=ppt/slides/slide56.xml><?xml version="1.0" encoding="utf-8"?>
+<file path=ppt/slides/slide53.xml><?xml version="1.0" encoding="utf-8"?>
 <p:sld xmlns:a="http://schemas.openxmlformats.org/drawingml/2006/main" xmlns:p="http://schemas.openxmlformats.org/presentationml/2006/main" xmlns:r="http://schemas.openxmlformats.org/officeDocument/2006/relationships">
   <p:cSld>
     <p:spTree>
@@ -30973,7 +30678,7 @@
 </p:sld>
 </file>
 
-<file path=ppt/slides/slide57.xml><?xml version="1.0" encoding="utf-8"?>
+<file path=ppt/slides/slide54.xml><?xml version="1.0" encoding="utf-8"?>
 <p:sld xmlns:a="http://schemas.openxmlformats.org/drawingml/2006/main" xmlns:p="http://schemas.openxmlformats.org/presentationml/2006/main" xmlns:r="http://schemas.openxmlformats.org/officeDocument/2006/relationships">
   <p:cSld>
     <p:spTree>
@@ -31765,7 +31470,7 @@
 </p:sld>
 </file>
 
-<file path=ppt/slides/slide58.xml><?xml version="1.0" encoding="utf-8"?>
+<file path=ppt/slides/slide55.xml><?xml version="1.0" encoding="utf-8"?>
 <p:sld xmlns:a="http://schemas.openxmlformats.org/drawingml/2006/main" xmlns:p="http://schemas.openxmlformats.org/presentationml/2006/main" xmlns:r="http://schemas.openxmlformats.org/officeDocument/2006/relationships">
   <p:cSld>
     <p:spTree>
@@ -31879,7 +31584,7 @@
 </p:sld>
 </file>
 
-<file path=ppt/slides/slide59.xml><?xml version="1.0" encoding="utf-8"?>
+<file path=ppt/slides/slide56.xml><?xml version="1.0" encoding="utf-8"?>
 <p:sld xmlns:a="http://schemas.openxmlformats.org/drawingml/2006/main" xmlns:p="http://schemas.openxmlformats.org/presentationml/2006/main" xmlns:r="http://schemas.openxmlformats.org/officeDocument/2006/relationships">
   <p:cSld>
     <p:spTree>
@@ -31985,7 +31690,7 @@
                 <a:ea typeface="Noto Sans CJK JP"/>
                 <a:cs typeface="Noto Sans"/>
               </a:rPr>
-              <a:t>第一著者はQi Zhu、最終著者はMinlie Huang。Kaili Huang、Zheng Zhang、Xiaoyan Zhuとともに、清華大学でデータとベースラインを構築した。</a:t>
+              <a:t>清華大学のQi Zhu、Kaili Huang、Zheng Zhang、Xiaoyan Zhu、Minlie Huangが、データセットとベースラインを構築した。</a:t>
             </a:r>
           </a:p>
           <a:p>
@@ -32160,6 +31865,416 @@
                 <a:hlinkClick r:id="rId2"/>
               </a:rPr>
               <a:t>https://aclanthology.org/2020.tacl-1.19/</a:t>
+            </a:r>
+          </a:p>
+        </p:txBody>
+      </p:sp>
+    </p:spTree>
+  </p:cSld>
+  <p:clrMapOvr>
+    <a:masterClrMapping/>
+  </p:clrMapOvr>
+</p:sld>
+</file>
+
+<file path=ppt/slides/slide57.xml><?xml version="1.0" encoding="utf-8"?>
+<p:sld xmlns:a="http://schemas.openxmlformats.org/drawingml/2006/main" xmlns:p="http://schemas.openxmlformats.org/presentationml/2006/main" xmlns:r="http://schemas.openxmlformats.org/officeDocument/2006/relationships">
+  <p:cSld>
+    <p:spTree>
+      <p:nvGrpSpPr>
+        <p:cNvPr id="1" name=""/>
+        <p:cNvGrpSpPr/>
+        <p:nvPr/>
+      </p:nvGrpSpPr>
+      <p:grpSpPr/>
+      <p:sp>
+        <p:nvSpPr>
+          <p:cNvPr id="2" name="Title 1"/>
+          <p:cNvSpPr>
+            <a:spLocks noGrp="1"/>
+          </p:cNvSpPr>
+          <p:nvPr>
+            <p:ph type="title"/>
+          </p:nvPr>
+        </p:nvSpPr>
+        <p:spPr>
+          <a:xfrm>
+            <a:off x="468172" y="650138"/>
+            <a:ext cx="8206740" cy="616305"/>
+          </a:xfrm>
+        </p:spPr>
+        <p:txBody>
+          <a:bodyPr wrap="square" lIns="0" rIns="0" tIns="0" bIns="0">
+            <a:noAutofit/>
+          </a:bodyPr>
+          <a:lstStyle/>
+          <a:p>
+            <a:pPr algn="l">
+              <a:lnSpc>
+                <a:spcPct val="110000"/>
+              </a:lnSpc>
+              <a:buNone/>
+              <a:defRPr sz="2800" b="0">
+                <a:solidFill>
+                  <a:srgbClr val="303437"/>
+                </a:solidFill>
+                <a:latin typeface="Noto Sans"/>
+              </a:defRPr>
+            </a:pPr>
+            <a:r>
+              <a:rPr sz="2800" b="1" lang="ja-JP" altLang="en-US">
+                <a:solidFill>
+                  <a:srgbClr val="303437"/>
+                </a:solidFill>
+                <a:latin typeface="Noto Sans"/>
+                <a:ea typeface="Noto Sans CJK JP"/>
+                <a:cs typeface="Noto Sans"/>
+              </a:rPr>
+              <a:t>参考文献</a:t>
+            </a:r>
+          </a:p>
+        </p:txBody>
+      </p:sp>
+      <p:sp>
+        <p:nvSpPr>
+          <p:cNvPr id="3" name="Title 2"/>
+          <p:cNvSpPr>
+            <a:spLocks noGrp="1"/>
+          </p:cNvSpPr>
+          <p:nvPr>
+            <p:ph type="title" idx="2"/>
+          </p:nvPr>
+        </p:nvSpPr>
+        <p:spPr>
+          <a:xfrm>
+            <a:off x="75895" y="0"/>
+            <a:ext cx="8115300" cy="480060"/>
+          </a:xfrm>
+        </p:spPr>
+        <p:txBody>
+          <a:bodyPr wrap="square" lIns="0" rIns="0" tIns="0" bIns="0" anchor="ctr">
+            <a:noAutofit/>
+          </a:bodyPr>
+          <a:lstStyle/>
+          <a:p>
+            <a:pPr algn="l">
+              <a:lnSpc>
+                <a:spcPct val="110000"/>
+              </a:lnSpc>
+              <a:buNone/>
+              <a:defRPr sz="1400" b="0">
+                <a:solidFill>
+                  <a:srgbClr val="303437"/>
+                </a:solidFill>
+                <a:latin typeface="Noto Sans"/>
+              </a:defRPr>
+            </a:pPr>
+            <a:r>
+              <a:rPr sz="1400" b="1" lang="ja-JP" altLang="en-US">
+                <a:solidFill>
+                  <a:srgbClr val="FFFEF8"/>
+                </a:solidFill>
+                <a:latin typeface="Noto Sans"/>
+                <a:ea typeface="Noto Sans CJK JP"/>
+                <a:cs typeface="Noto Sans"/>
+              </a:rPr>
+              <a:t>Appendix: 3. 研究と参考文献</a:t>
+            </a:r>
+          </a:p>
+        </p:txBody>
+      </p:sp>
+      <p:sp>
+        <p:nvSpPr>
+          <p:cNvPr id="4" name="文献 1: CrossWOZ: A Large-Scale Chinese Cross-Domain Task-Oriented Dialogue Dataset"/>
+          <p:cNvSpPr txBox="1"/>
+          <p:nvPr/>
+        </p:nvSpPr>
+        <p:spPr>
+          <a:xfrm>
+            <a:off x="548640" y="1417320"/>
+            <a:ext cx="8046720" cy="1849045"/>
+          </a:xfrm>
+          <a:prstGeom prst="rect">
+            <a:avLst/>
+          </a:prstGeom>
+          <a:noFill/>
+        </p:spPr>
+        <p:txBody>
+          <a:bodyPr wrap="square" lIns="0" rIns="0" tIns="0" bIns="0">
+            <a:noAutofit/>
+          </a:bodyPr>
+          <a:lstStyle/>
+          <a:p>
+            <a:pPr algn="l">
+              <a:lnSpc>
+                <a:spcPct val="114000"/>
+              </a:lnSpc>
+              <a:spcBef>
+                <a:spcPts val="0"/>
+              </a:spcBef>
+              <a:spcAft>
+                <a:spcPts val="400"/>
+              </a:spcAft>
+              <a:buNone/>
+              <a:defRPr sz="1800" b="0">
+                <a:solidFill>
+                  <a:srgbClr val="303437"/>
+                </a:solidFill>
+                <a:latin typeface="Noto Sans"/>
+              </a:defRPr>
+            </a:pPr>
+            <a:r>
+              <a:rPr sz="1800" b="1" lang="ja-JP" altLang="en-US">
+                <a:solidFill>
+                  <a:srgbClr val="303437"/>
+                </a:solidFill>
+                <a:latin typeface="Noto Sans"/>
+                <a:ea typeface="Noto Sans CJK JP"/>
+                <a:cs typeface="Noto Sans"/>
+              </a:rPr>
+              <a:t>CrossWOZ: A Large-Scale Chinese Cross-Domain Task-Oriented Dialogue Dataset</a:t>
+            </a:r>
+          </a:p>
+          <a:p>
+            <a:pPr algn="l">
+              <a:lnSpc>
+                <a:spcPct val="114000"/>
+              </a:lnSpc>
+              <a:spcBef>
+                <a:spcPts val="0"/>
+              </a:spcBef>
+              <a:spcAft>
+                <a:spcPts val="500"/>
+              </a:spcAft>
+              <a:buNone/>
+              <a:defRPr sz="1250" b="0">
+                <a:solidFill>
+                  <a:srgbClr val="303437"/>
+                </a:solidFill>
+                <a:latin typeface="Noto Sans"/>
+              </a:defRPr>
+            </a:pPr>
+            <a:r>
+              <a:rPr sz="1250" b="0" lang="ja-JP" altLang="en-US">
+                <a:solidFill>
+                  <a:srgbClr val="626669"/>
+                </a:solidFill>
+                <a:latin typeface="Noto Sans"/>
+                <a:ea typeface="Noto Sans CJK JP"/>
+                <a:cs typeface="Noto Sans"/>
+              </a:rPr>
+              <a:t>Qi Zhu, Kaili Huang, Zheng Zhang, Xiaoyan Zhu, Minlie Huang (2020). TACL8:281–295.</a:t>
+            </a:r>
+          </a:p>
+          <a:p>
+            <a:pPr algn="l">
+              <a:lnSpc>
+                <a:spcPct val="114000"/>
+              </a:lnSpc>
+              <a:spcBef>
+                <a:spcPts val="0"/>
+              </a:spcBef>
+              <a:spcAft>
+                <a:spcPts val="400"/>
+              </a:spcAft>
+              <a:buNone/>
+              <a:defRPr sz="1750" b="0">
+                <a:solidFill>
+                  <a:srgbClr val="303437"/>
+                </a:solidFill>
+                <a:latin typeface="Noto Sans"/>
+              </a:defRPr>
+            </a:pPr>
+            <a:r>
+              <a:rPr sz="1750" b="0" lang="ja-JP" altLang="en-US">
+                <a:solidFill>
+                  <a:srgbClr val="303437"/>
+                </a:solidFill>
+                <a:latin typeface="Noto Sans"/>
+                <a:ea typeface="Noto Sans CJK JP"/>
+                <a:cs typeface="Noto Sans"/>
+              </a:rPr>
+              <a:t>北京の旅行案内を人間同士で収集し、領域間の依存を持つ目標、状態・行為の注釈と部品別評価を提示する。</a:t>
+            </a:r>
+          </a:p>
+          <a:p>
+            <a:pPr algn="l">
+              <a:lnSpc>
+                <a:spcPct val="114000"/>
+              </a:lnSpc>
+              <a:spcBef>
+                <a:spcPts val="0"/>
+              </a:spcBef>
+              <a:spcAft>
+                <a:spcPts val="0"/>
+              </a:spcAft>
+              <a:buNone/>
+              <a:defRPr sz="1050" b="0">
+                <a:solidFill>
+                  <a:srgbClr val="303437"/>
+                </a:solidFill>
+                <a:latin typeface="Noto Sans"/>
+              </a:defRPr>
+            </a:pPr>
+            <a:r>
+              <a:rPr sz="1050" b="0" lang="ja-JP" altLang="en-US">
+                <a:solidFill>
+                  <a:srgbClr val="626669"/>
+                </a:solidFill>
+                <a:latin typeface="Noto Sans"/>
+                <a:ea typeface="Noto Sans CJK JP"/>
+                <a:cs typeface="Noto Sans"/>
+                <a:hlinkClick r:id="rId2"/>
+              </a:rPr>
+              <a:t>https://aclanthology.org/2020.tacl-1.19/</a:t>
+            </a:r>
+          </a:p>
+        </p:txBody>
+      </p:sp>
+      <p:sp>
+        <p:nvSpPr>
+          <p:cNvPr id="5" name="文献 2: CrossWOZ"/>
+          <p:cNvSpPr txBox="1"/>
+          <p:nvPr/>
+        </p:nvSpPr>
+        <p:spPr>
+          <a:xfrm>
+            <a:off x="548640" y="3248152"/>
+            <a:ext cx="8046720" cy="1537057"/>
+          </a:xfrm>
+          <a:prstGeom prst="rect">
+            <a:avLst/>
+          </a:prstGeom>
+          <a:noFill/>
+        </p:spPr>
+        <p:txBody>
+          <a:bodyPr wrap="square" lIns="0" rIns="0" tIns="0" bIns="0">
+            <a:noAutofit/>
+          </a:bodyPr>
+          <a:lstStyle/>
+          <a:p>
+            <a:pPr algn="l">
+              <a:lnSpc>
+                <a:spcPct val="114000"/>
+              </a:lnSpc>
+              <a:spcBef>
+                <a:spcPts val="0"/>
+              </a:spcBef>
+              <a:spcAft>
+                <a:spcPts val="400"/>
+              </a:spcAft>
+              <a:buNone/>
+              <a:defRPr sz="1800" b="0">
+                <a:solidFill>
+                  <a:srgbClr val="303437"/>
+                </a:solidFill>
+                <a:latin typeface="Noto Sans"/>
+              </a:defRPr>
+            </a:pPr>
+            <a:r>
+              <a:rPr sz="1800" b="1" lang="ja-JP" altLang="en-US">
+                <a:solidFill>
+                  <a:srgbClr val="303437"/>
+                </a:solidFill>
+                <a:latin typeface="Noto Sans"/>
+                <a:ea typeface="Noto Sans CJK JP"/>
+                <a:cs typeface="Noto Sans"/>
+              </a:rPr>
+              <a:t>CrossWOZ</a:t>
+            </a:r>
+          </a:p>
+          <a:p>
+            <a:pPr algn="l">
+              <a:lnSpc>
+                <a:spcPct val="114000"/>
+              </a:lnSpc>
+              <a:spcBef>
+                <a:spcPts val="0"/>
+              </a:spcBef>
+              <a:spcAft>
+                <a:spcPts val="500"/>
+              </a:spcAft>
+              <a:buNone/>
+              <a:defRPr sz="1250" b="0">
+                <a:solidFill>
+                  <a:srgbClr val="303437"/>
+                </a:solidFill>
+                <a:latin typeface="Noto Sans"/>
+              </a:defRPr>
+            </a:pPr>
+            <a:r>
+              <a:rPr sz="1250" b="0" lang="ja-JP" altLang="en-US">
+                <a:solidFill>
+                  <a:srgbClr val="626669"/>
+                </a:solidFill>
+                <a:latin typeface="Noto Sans"/>
+                <a:ea typeface="Noto Sans CJK JP"/>
+                <a:cs typeface="Noto Sans"/>
+              </a:rPr>
+              <a:t>Qi Zhu et al. (n.d.). 公式リポジトリ。参照2026-10-18。</a:t>
+            </a:r>
+          </a:p>
+          <a:p>
+            <a:pPr algn="l">
+              <a:lnSpc>
+                <a:spcPct val="114000"/>
+              </a:lnSpc>
+              <a:spcBef>
+                <a:spcPts val="0"/>
+              </a:spcBef>
+              <a:spcAft>
+                <a:spcPts val="400"/>
+              </a:spcAft>
+              <a:buNone/>
+              <a:defRPr sz="1750" b="0">
+                <a:solidFill>
+                  <a:srgbClr val="303437"/>
+                </a:solidFill>
+                <a:latin typeface="Noto Sans"/>
+              </a:defRPr>
+            </a:pPr>
+            <a:r>
+              <a:rPr sz="1750" b="0" lang="ja-JP" altLang="en-US">
+                <a:solidFill>
+                  <a:srgbClr val="303437"/>
+                </a:solidFill>
+                <a:latin typeface="Noto Sans"/>
+                <a:ea typeface="Noto Sans CJK JP"/>
+                <a:cs typeface="Noto Sans"/>
+              </a:rPr>
+              <a:t>対話3分割、施設DB、状態追跡や方策・生成のコード、収集プラットフォームを配布する。</a:t>
+            </a:r>
+          </a:p>
+          <a:p>
+            <a:pPr algn="l">
+              <a:lnSpc>
+                <a:spcPct val="114000"/>
+              </a:lnSpc>
+              <a:spcBef>
+                <a:spcPts val="0"/>
+              </a:spcBef>
+              <a:spcAft>
+                <a:spcPts val="0"/>
+              </a:spcAft>
+              <a:buNone/>
+              <a:defRPr sz="1050" b="0">
+                <a:solidFill>
+                  <a:srgbClr val="303437"/>
+                </a:solidFill>
+                <a:latin typeface="Noto Sans"/>
+              </a:defRPr>
+            </a:pPr>
+            <a:r>
+              <a:rPr sz="1050" b="0" lang="ja-JP" altLang="en-US">
+                <a:solidFill>
+                  <a:srgbClr val="626669"/>
+                </a:solidFill>
+                <a:latin typeface="Noto Sans"/>
+                <a:ea typeface="Noto Sans CJK JP"/>
+                <a:cs typeface="Noto Sans"/>
+                <a:hlinkClick r:id="rId3"/>
+              </a:rPr>
+              <a:t>https://github.com/thu-coai/CrossWOZ</a:t>
             </a:r>
           </a:p>
         </p:txBody>
@@ -32423,826 +32538,6 @@
                 <a:hlinkClick r:id="rId3"/>
               </a:rPr>
               <a:t>https://github.com/thu-coai/CrossWOZ/tree/master/data/crosswoz</a:t>
-            </a:r>
-          </a:p>
-        </p:txBody>
-      </p:sp>
-    </p:spTree>
-  </p:cSld>
-  <p:clrMapOvr>
-    <a:masterClrMapping/>
-  </p:clrMapOvr>
-</p:sld>
-</file>
-
-<file path=ppt/slides/slide60.xml><?xml version="1.0" encoding="utf-8"?>
-<p:sld xmlns:a="http://schemas.openxmlformats.org/drawingml/2006/main" xmlns:p="http://schemas.openxmlformats.org/presentationml/2006/main" xmlns:r="http://schemas.openxmlformats.org/officeDocument/2006/relationships">
-  <p:cSld>
-    <p:spTree>
-      <p:nvGrpSpPr>
-        <p:cNvPr id="1" name=""/>
-        <p:cNvGrpSpPr/>
-        <p:nvPr/>
-      </p:nvGrpSpPr>
-      <p:grpSpPr/>
-      <p:sp>
-        <p:nvSpPr>
-          <p:cNvPr id="2" name="Title 1"/>
-          <p:cNvSpPr>
-            <a:spLocks noGrp="1"/>
-          </p:cNvSpPr>
-          <p:nvPr>
-            <p:ph type="title"/>
-          </p:nvPr>
-        </p:nvSpPr>
-        <p:spPr>
-          <a:xfrm>
-            <a:off x="468172" y="650138"/>
-            <a:ext cx="8206740" cy="616305"/>
-          </a:xfrm>
-        </p:spPr>
-        <p:txBody>
-          <a:bodyPr wrap="square" lIns="0" rIns="0" tIns="0" bIns="0">
-            <a:noAutofit/>
-          </a:bodyPr>
-          <a:lstStyle/>
-          <a:p>
-            <a:pPr algn="l">
-              <a:lnSpc>
-                <a:spcPct val="110000"/>
-              </a:lnSpc>
-              <a:buNone/>
-              <a:defRPr sz="2800" b="0">
-                <a:solidFill>
-                  <a:srgbClr val="303437"/>
-                </a:solidFill>
-                <a:latin typeface="Noto Sans"/>
-              </a:defRPr>
-            </a:pPr>
-            <a:r>
-              <a:rPr sz="2800" b="1" lang="ja-JP" altLang="en-US">
-                <a:solidFill>
-                  <a:srgbClr val="303437"/>
-                </a:solidFill>
-                <a:latin typeface="Noto Sans"/>
-                <a:ea typeface="Noto Sans CJK JP"/>
-                <a:cs typeface="Noto Sans"/>
-              </a:rPr>
-              <a:t>参考文献</a:t>
-            </a:r>
-          </a:p>
-        </p:txBody>
-      </p:sp>
-      <p:sp>
-        <p:nvSpPr>
-          <p:cNvPr id="3" name="Title 2"/>
-          <p:cNvSpPr>
-            <a:spLocks noGrp="1"/>
-          </p:cNvSpPr>
-          <p:nvPr>
-            <p:ph type="title" idx="2"/>
-          </p:nvPr>
-        </p:nvSpPr>
-        <p:spPr>
-          <a:xfrm>
-            <a:off x="75895" y="0"/>
-            <a:ext cx="8115300" cy="480060"/>
-          </a:xfrm>
-        </p:spPr>
-        <p:txBody>
-          <a:bodyPr wrap="square" lIns="0" rIns="0" tIns="0" bIns="0" anchor="ctr">
-            <a:noAutofit/>
-          </a:bodyPr>
-          <a:lstStyle/>
-          <a:p>
-            <a:pPr algn="l">
-              <a:lnSpc>
-                <a:spcPct val="110000"/>
-              </a:lnSpc>
-              <a:buNone/>
-              <a:defRPr sz="1400" b="0">
-                <a:solidFill>
-                  <a:srgbClr val="303437"/>
-                </a:solidFill>
-                <a:latin typeface="Noto Sans"/>
-              </a:defRPr>
-            </a:pPr>
-            <a:r>
-              <a:rPr sz="1400" b="1" lang="ja-JP" altLang="en-US">
-                <a:solidFill>
-                  <a:srgbClr val="FFFEF8"/>
-                </a:solidFill>
-                <a:latin typeface="Noto Sans"/>
-                <a:ea typeface="Noto Sans CJK JP"/>
-                <a:cs typeface="Noto Sans"/>
-              </a:rPr>
-              <a:t>Appendix: 3. 研究と参考文献</a:t>
-            </a:r>
-          </a:p>
-        </p:txBody>
-      </p:sp>
-      <p:sp>
-        <p:nvSpPr>
-          <p:cNvPr id="4" name="文献 1: CrossWOZ: A Large-Scale Chinese Cross-Domain Task-Oriented Dialogue Dataset"/>
-          <p:cNvSpPr txBox="1"/>
-          <p:nvPr/>
-        </p:nvSpPr>
-        <p:spPr>
-          <a:xfrm>
-            <a:off x="548640" y="1417320"/>
-            <a:ext cx="8046720" cy="1849045"/>
-          </a:xfrm>
-          <a:prstGeom prst="rect">
-            <a:avLst/>
-          </a:prstGeom>
-          <a:noFill/>
-        </p:spPr>
-        <p:txBody>
-          <a:bodyPr wrap="square" lIns="0" rIns="0" tIns="0" bIns="0">
-            <a:noAutofit/>
-          </a:bodyPr>
-          <a:lstStyle/>
-          <a:p>
-            <a:pPr algn="l">
-              <a:lnSpc>
-                <a:spcPct val="114000"/>
-              </a:lnSpc>
-              <a:spcBef>
-                <a:spcPts val="0"/>
-              </a:spcBef>
-              <a:spcAft>
-                <a:spcPts val="400"/>
-              </a:spcAft>
-              <a:buNone/>
-              <a:defRPr sz="1800" b="0">
-                <a:solidFill>
-                  <a:srgbClr val="303437"/>
-                </a:solidFill>
-                <a:latin typeface="Noto Sans"/>
-              </a:defRPr>
-            </a:pPr>
-            <a:r>
-              <a:rPr sz="1800" b="1" lang="ja-JP" altLang="en-US">
-                <a:solidFill>
-                  <a:srgbClr val="303437"/>
-                </a:solidFill>
-                <a:latin typeface="Noto Sans"/>
-                <a:ea typeface="Noto Sans CJK JP"/>
-                <a:cs typeface="Noto Sans"/>
-              </a:rPr>
-              <a:t>CrossWOZ: A Large-Scale Chinese Cross-Domain Task-Oriented Dialogue Dataset</a:t>
-            </a:r>
-          </a:p>
-          <a:p>
-            <a:pPr algn="l">
-              <a:lnSpc>
-                <a:spcPct val="114000"/>
-              </a:lnSpc>
-              <a:spcBef>
-                <a:spcPts val="0"/>
-              </a:spcBef>
-              <a:spcAft>
-                <a:spcPts val="500"/>
-              </a:spcAft>
-              <a:buNone/>
-              <a:defRPr sz="1250" b="0">
-                <a:solidFill>
-                  <a:srgbClr val="303437"/>
-                </a:solidFill>
-                <a:latin typeface="Noto Sans"/>
-              </a:defRPr>
-            </a:pPr>
-            <a:r>
-              <a:rPr sz="1250" b="0" lang="ja-JP" altLang="en-US">
-                <a:solidFill>
-                  <a:srgbClr val="626669"/>
-                </a:solidFill>
-                <a:latin typeface="Noto Sans"/>
-                <a:ea typeface="Noto Sans CJK JP"/>
-                <a:cs typeface="Noto Sans"/>
-              </a:rPr>
-              <a:t>Qi Zhu, Kaili Huang, Zheng Zhang, Xiaoyan Zhu, Minlie Huang (2020). TACL8:281–295.</a:t>
-            </a:r>
-          </a:p>
-          <a:p>
-            <a:pPr algn="l">
-              <a:lnSpc>
-                <a:spcPct val="114000"/>
-              </a:lnSpc>
-              <a:spcBef>
-                <a:spcPts val="0"/>
-              </a:spcBef>
-              <a:spcAft>
-                <a:spcPts val="400"/>
-              </a:spcAft>
-              <a:buNone/>
-              <a:defRPr sz="1750" b="0">
-                <a:solidFill>
-                  <a:srgbClr val="303437"/>
-                </a:solidFill>
-                <a:latin typeface="Noto Sans"/>
-              </a:defRPr>
-            </a:pPr>
-            <a:r>
-              <a:rPr sz="1750" b="0" lang="ja-JP" altLang="en-US">
-                <a:solidFill>
-                  <a:srgbClr val="303437"/>
-                </a:solidFill>
-                <a:latin typeface="Noto Sans"/>
-                <a:ea typeface="Noto Sans CJK JP"/>
-                <a:cs typeface="Noto Sans"/>
-              </a:rPr>
-              <a:t>北京の旅行案内を人間同士で収集し、領域間の依存を持つ目標、状態・行為の注釈と部品別評価を提示する。</a:t>
-            </a:r>
-          </a:p>
-          <a:p>
-            <a:pPr algn="l">
-              <a:lnSpc>
-                <a:spcPct val="114000"/>
-              </a:lnSpc>
-              <a:spcBef>
-                <a:spcPts val="0"/>
-              </a:spcBef>
-              <a:spcAft>
-                <a:spcPts val="0"/>
-              </a:spcAft>
-              <a:buNone/>
-              <a:defRPr sz="1050" b="0">
-                <a:solidFill>
-                  <a:srgbClr val="303437"/>
-                </a:solidFill>
-                <a:latin typeface="Noto Sans"/>
-              </a:defRPr>
-            </a:pPr>
-            <a:r>
-              <a:rPr sz="1050" b="0" lang="ja-JP" altLang="en-US">
-                <a:solidFill>
-                  <a:srgbClr val="626669"/>
-                </a:solidFill>
-                <a:latin typeface="Noto Sans"/>
-                <a:ea typeface="Noto Sans CJK JP"/>
-                <a:cs typeface="Noto Sans"/>
-                <a:hlinkClick r:id="rId2"/>
-              </a:rPr>
-              <a:t>https://aclanthology.org/2020.tacl-1.19/</a:t>
-            </a:r>
-          </a:p>
-        </p:txBody>
-      </p:sp>
-      <p:sp>
-        <p:nvSpPr>
-          <p:cNvPr id="5" name="文献 2: CrossWOZ"/>
-          <p:cNvSpPr txBox="1"/>
-          <p:nvPr/>
-        </p:nvSpPr>
-        <p:spPr>
-          <a:xfrm>
-            <a:off x="548640" y="3248152"/>
-            <a:ext cx="8046720" cy="1537057"/>
-          </a:xfrm>
-          <a:prstGeom prst="rect">
-            <a:avLst/>
-          </a:prstGeom>
-          <a:noFill/>
-        </p:spPr>
-        <p:txBody>
-          <a:bodyPr wrap="square" lIns="0" rIns="0" tIns="0" bIns="0">
-            <a:noAutofit/>
-          </a:bodyPr>
-          <a:lstStyle/>
-          <a:p>
-            <a:pPr algn="l">
-              <a:lnSpc>
-                <a:spcPct val="114000"/>
-              </a:lnSpc>
-              <a:spcBef>
-                <a:spcPts val="0"/>
-              </a:spcBef>
-              <a:spcAft>
-                <a:spcPts val="400"/>
-              </a:spcAft>
-              <a:buNone/>
-              <a:defRPr sz="1800" b="0">
-                <a:solidFill>
-                  <a:srgbClr val="303437"/>
-                </a:solidFill>
-                <a:latin typeface="Noto Sans"/>
-              </a:defRPr>
-            </a:pPr>
-            <a:r>
-              <a:rPr sz="1800" b="1" lang="ja-JP" altLang="en-US">
-                <a:solidFill>
-                  <a:srgbClr val="303437"/>
-                </a:solidFill>
-                <a:latin typeface="Noto Sans"/>
-                <a:ea typeface="Noto Sans CJK JP"/>
-                <a:cs typeface="Noto Sans"/>
-              </a:rPr>
-              <a:t>CrossWOZ</a:t>
-            </a:r>
-          </a:p>
-          <a:p>
-            <a:pPr algn="l">
-              <a:lnSpc>
-                <a:spcPct val="114000"/>
-              </a:lnSpc>
-              <a:spcBef>
-                <a:spcPts val="0"/>
-              </a:spcBef>
-              <a:spcAft>
-                <a:spcPts val="500"/>
-              </a:spcAft>
-              <a:buNone/>
-              <a:defRPr sz="1250" b="0">
-                <a:solidFill>
-                  <a:srgbClr val="303437"/>
-                </a:solidFill>
-                <a:latin typeface="Noto Sans"/>
-              </a:defRPr>
-            </a:pPr>
-            <a:r>
-              <a:rPr sz="1250" b="0" lang="ja-JP" altLang="en-US">
-                <a:solidFill>
-                  <a:srgbClr val="626669"/>
-                </a:solidFill>
-                <a:latin typeface="Noto Sans"/>
-                <a:ea typeface="Noto Sans CJK JP"/>
-                <a:cs typeface="Noto Sans"/>
-              </a:rPr>
-              <a:t>Qi Zhu et al. 公式リポジトリ。</a:t>
-            </a:r>
-          </a:p>
-          <a:p>
-            <a:pPr algn="l">
-              <a:lnSpc>
-                <a:spcPct val="114000"/>
-              </a:lnSpc>
-              <a:spcBef>
-                <a:spcPts val="0"/>
-              </a:spcBef>
-              <a:spcAft>
-                <a:spcPts val="400"/>
-              </a:spcAft>
-              <a:buNone/>
-              <a:defRPr sz="1750" b="0">
-                <a:solidFill>
-                  <a:srgbClr val="303437"/>
-                </a:solidFill>
-                <a:latin typeface="Noto Sans"/>
-              </a:defRPr>
-            </a:pPr>
-            <a:r>
-              <a:rPr sz="1750" b="0" lang="ja-JP" altLang="en-US">
-                <a:solidFill>
-                  <a:srgbClr val="303437"/>
-                </a:solidFill>
-                <a:latin typeface="Noto Sans"/>
-                <a:ea typeface="Noto Sans CJK JP"/>
-                <a:cs typeface="Noto Sans"/>
-              </a:rPr>
-              <a:t>対話3分割、施設DB、状態追跡や方策・生成のコード、収集プラットフォームを配布する。</a:t>
-            </a:r>
-          </a:p>
-          <a:p>
-            <a:pPr algn="l">
-              <a:lnSpc>
-                <a:spcPct val="114000"/>
-              </a:lnSpc>
-              <a:spcBef>
-                <a:spcPts val="0"/>
-              </a:spcBef>
-              <a:spcAft>
-                <a:spcPts val="0"/>
-              </a:spcAft>
-              <a:buNone/>
-              <a:defRPr sz="1050" b="0">
-                <a:solidFill>
-                  <a:srgbClr val="303437"/>
-                </a:solidFill>
-                <a:latin typeface="Noto Sans"/>
-              </a:defRPr>
-            </a:pPr>
-            <a:r>
-              <a:rPr sz="1050" b="0" lang="ja-JP" altLang="en-US">
-                <a:solidFill>
-                  <a:srgbClr val="626669"/>
-                </a:solidFill>
-                <a:latin typeface="Noto Sans"/>
-                <a:ea typeface="Noto Sans CJK JP"/>
-                <a:cs typeface="Noto Sans"/>
-                <a:hlinkClick r:id="rId3"/>
-              </a:rPr>
-              <a:t>https://github.com/thu-coai/CrossWOZ</a:t>
-            </a:r>
-          </a:p>
-        </p:txBody>
-      </p:sp>
-    </p:spTree>
-  </p:cSld>
-  <p:clrMapOvr>
-    <a:masterClrMapping/>
-  </p:clrMapOvr>
-</p:sld>
-</file>
-
-<file path=ppt/slides/slide61.xml><?xml version="1.0" encoding="utf-8"?>
-<p:sld xmlns:a="http://schemas.openxmlformats.org/drawingml/2006/main" xmlns:p="http://schemas.openxmlformats.org/presentationml/2006/main" xmlns:r="http://schemas.openxmlformats.org/officeDocument/2006/relationships">
-  <p:cSld>
-    <p:spTree>
-      <p:nvGrpSpPr>
-        <p:cNvPr id="1" name=""/>
-        <p:cNvGrpSpPr/>
-        <p:nvPr/>
-      </p:nvGrpSpPr>
-      <p:grpSpPr/>
-      <p:sp>
-        <p:nvSpPr>
-          <p:cNvPr id="2" name="Title 1"/>
-          <p:cNvSpPr>
-            <a:spLocks noGrp="1"/>
-          </p:cNvSpPr>
-          <p:nvPr>
-            <p:ph type="title"/>
-          </p:nvPr>
-        </p:nvSpPr>
-        <p:spPr>
-          <a:xfrm>
-            <a:off x="468172" y="650138"/>
-            <a:ext cx="8206740" cy="616305"/>
-          </a:xfrm>
-        </p:spPr>
-        <p:txBody>
-          <a:bodyPr wrap="square" lIns="0" rIns="0" tIns="0" bIns="0">
-            <a:noAutofit/>
-          </a:bodyPr>
-          <a:lstStyle/>
-          <a:p>
-            <a:pPr algn="l">
-              <a:lnSpc>
-                <a:spcPct val="110000"/>
-              </a:lnSpc>
-              <a:buNone/>
-              <a:defRPr sz="2800" b="0">
-                <a:solidFill>
-                  <a:srgbClr val="303437"/>
-                </a:solidFill>
-                <a:latin typeface="Noto Sans"/>
-              </a:defRPr>
-            </a:pPr>
-            <a:r>
-              <a:rPr sz="2800" b="1" lang="ja-JP" altLang="en-US">
-                <a:solidFill>
-                  <a:srgbClr val="303437"/>
-                </a:solidFill>
-                <a:latin typeface="Noto Sans"/>
-                <a:ea typeface="Noto Sans CJK JP"/>
-                <a:cs typeface="Noto Sans"/>
-              </a:rPr>
-              <a:t>参考文献</a:t>
-            </a:r>
-          </a:p>
-        </p:txBody>
-      </p:sp>
-      <p:sp>
-        <p:nvSpPr>
-          <p:cNvPr id="3" name="Title 2"/>
-          <p:cNvSpPr>
-            <a:spLocks noGrp="1"/>
-          </p:cNvSpPr>
-          <p:nvPr>
-            <p:ph type="title" idx="2"/>
-          </p:nvPr>
-        </p:nvSpPr>
-        <p:spPr>
-          <a:xfrm>
-            <a:off x="75895" y="0"/>
-            <a:ext cx="8115300" cy="480060"/>
-          </a:xfrm>
-        </p:spPr>
-        <p:txBody>
-          <a:bodyPr wrap="square" lIns="0" rIns="0" tIns="0" bIns="0" anchor="ctr">
-            <a:noAutofit/>
-          </a:bodyPr>
-          <a:lstStyle/>
-          <a:p>
-            <a:pPr algn="l">
-              <a:lnSpc>
-                <a:spcPct val="110000"/>
-              </a:lnSpc>
-              <a:buNone/>
-              <a:defRPr sz="1400" b="0">
-                <a:solidFill>
-                  <a:srgbClr val="303437"/>
-                </a:solidFill>
-                <a:latin typeface="Noto Sans"/>
-              </a:defRPr>
-            </a:pPr>
-            <a:r>
-              <a:rPr sz="1400" b="1" lang="ja-JP" altLang="en-US">
-                <a:solidFill>
-                  <a:srgbClr val="FFFEF8"/>
-                </a:solidFill>
-                <a:latin typeface="Noto Sans"/>
-                <a:ea typeface="Noto Sans CJK JP"/>
-                <a:cs typeface="Noto Sans"/>
-              </a:rPr>
-              <a:t>Appendix: 3. 研究と参考文献</a:t>
-            </a:r>
-          </a:p>
-        </p:txBody>
-      </p:sp>
-      <p:sp>
-        <p:nvSpPr>
-          <p:cNvPr id="4" name="文献 1: CLEVA: Chinese Language Models EVAluation Platform"/>
-          <p:cNvSpPr txBox="1"/>
-          <p:nvPr/>
-        </p:nvSpPr>
-        <p:spPr>
-          <a:xfrm>
-            <a:off x="548640" y="1417320"/>
-            <a:ext cx="8046720" cy="1233451"/>
-          </a:xfrm>
-          <a:prstGeom prst="rect">
-            <a:avLst/>
-          </a:prstGeom>
-          <a:noFill/>
-        </p:spPr>
-        <p:txBody>
-          <a:bodyPr wrap="square" lIns="0" rIns="0" tIns="0" bIns="0">
-            <a:noAutofit/>
-          </a:bodyPr>
-          <a:lstStyle/>
-          <a:p>
-            <a:pPr algn="l">
-              <a:lnSpc>
-                <a:spcPct val="114000"/>
-              </a:lnSpc>
-              <a:spcBef>
-                <a:spcPts val="0"/>
-              </a:spcBef>
-              <a:spcAft>
-                <a:spcPts val="400"/>
-              </a:spcAft>
-              <a:buNone/>
-              <a:defRPr sz="1800" b="0">
-                <a:solidFill>
-                  <a:srgbClr val="303437"/>
-                </a:solidFill>
-                <a:latin typeface="Noto Sans"/>
-              </a:defRPr>
-            </a:pPr>
-            <a:r>
-              <a:rPr sz="1800" b="1" lang="ja-JP" altLang="en-US">
-                <a:solidFill>
-                  <a:srgbClr val="303437"/>
-                </a:solidFill>
-                <a:latin typeface="Noto Sans"/>
-                <a:ea typeface="Noto Sans CJK JP"/>
-                <a:cs typeface="Noto Sans"/>
-              </a:rPr>
-              <a:t>CLEVA: Chinese Language Models EVAluation Platform</a:t>
-            </a:r>
-          </a:p>
-          <a:p>
-            <a:pPr algn="l">
-              <a:lnSpc>
-                <a:spcPct val="114000"/>
-              </a:lnSpc>
-              <a:spcBef>
-                <a:spcPts val="0"/>
-              </a:spcBef>
-              <a:spcAft>
-                <a:spcPts val="500"/>
-              </a:spcAft>
-              <a:buNone/>
-              <a:defRPr sz="1250" b="0">
-                <a:solidFill>
-                  <a:srgbClr val="303437"/>
-                </a:solidFill>
-                <a:latin typeface="Noto Sans"/>
-              </a:defRPr>
-            </a:pPr>
-            <a:r>
-              <a:rPr sz="1250" b="0" lang="ja-JP" altLang="en-US">
-                <a:solidFill>
-                  <a:srgbClr val="626669"/>
-                </a:solidFill>
-                <a:latin typeface="Noto Sans"/>
-                <a:ea typeface="Noto Sans CJK JP"/>
-                <a:cs typeface="Noto Sans"/>
-              </a:rPr>
-              <a:t>Yanyang Li, Jianqiao Zhao et al. (2023). EMNLP System Demonstrations, pp.186–217.</a:t>
-            </a:r>
-          </a:p>
-          <a:p>
-            <a:pPr algn="l">
-              <a:lnSpc>
-                <a:spcPct val="114000"/>
-              </a:lnSpc>
-              <a:spcBef>
-                <a:spcPts val="0"/>
-              </a:spcBef>
-              <a:spcAft>
-                <a:spcPts val="400"/>
-              </a:spcAft>
-              <a:buNone/>
-              <a:defRPr sz="1750" b="0">
-                <a:solidFill>
-                  <a:srgbClr val="303437"/>
-                </a:solidFill>
-                <a:latin typeface="Noto Sans"/>
-              </a:defRPr>
-            </a:pPr>
-            <a:r>
-              <a:rPr sz="1750" b="0" lang="ja-JP" altLang="en-US">
-                <a:solidFill>
-                  <a:srgbClr val="303437"/>
-                </a:solidFill>
-                <a:latin typeface="Noto Sans"/>
-                <a:ea typeface="Noto Sans CJK JP"/>
-                <a:cs typeface="Noto Sans"/>
-              </a:rPr>
-              <a:t>中国語評価の基盤を提案し、CrossWOZを対話生成の採用元として説明する。</a:t>
-            </a:r>
-          </a:p>
-          <a:p>
-            <a:pPr algn="l">
-              <a:lnSpc>
-                <a:spcPct val="114000"/>
-              </a:lnSpc>
-              <a:spcBef>
-                <a:spcPts val="0"/>
-              </a:spcBef>
-              <a:spcAft>
-                <a:spcPts val="0"/>
-              </a:spcAft>
-              <a:buNone/>
-              <a:defRPr sz="1050" b="0">
-                <a:solidFill>
-                  <a:srgbClr val="303437"/>
-                </a:solidFill>
-                <a:latin typeface="Noto Sans"/>
-              </a:defRPr>
-            </a:pPr>
-            <a:r>
-              <a:rPr sz="1050" b="0" lang="ja-JP" altLang="en-US">
-                <a:solidFill>
-                  <a:srgbClr val="626669"/>
-                </a:solidFill>
-                <a:latin typeface="Noto Sans"/>
-                <a:ea typeface="Noto Sans CJK JP"/>
-                <a:cs typeface="Noto Sans"/>
-                <a:hlinkClick r:id="rId2"/>
-              </a:rPr>
-              <a:t>https://aclanthology.org/2023.emnlp-demo.17/</a:t>
-            </a:r>
-          </a:p>
-        </p:txBody>
-      </p:sp>
-      <p:sp>
-        <p:nvSpPr>
-          <p:cNvPr id="5" name="文献 2: CLEVA Scenario and v1 Run Configuration"/>
-          <p:cNvSpPr txBox="1"/>
-          <p:nvPr/>
-        </p:nvSpPr>
-        <p:spPr>
-          <a:xfrm>
-            <a:off x="548640" y="2734183"/>
-            <a:ext cx="8046720" cy="1536587"/>
-          </a:xfrm>
-          <a:prstGeom prst="rect">
-            <a:avLst/>
-          </a:prstGeom>
-          <a:noFill/>
-        </p:spPr>
-        <p:txBody>
-          <a:bodyPr wrap="square" lIns="0" rIns="0" tIns="0" bIns="0">
-            <a:noAutofit/>
-          </a:bodyPr>
-          <a:lstStyle/>
-          <a:p>
-            <a:pPr algn="l">
-              <a:lnSpc>
-                <a:spcPct val="114000"/>
-              </a:lnSpc>
-              <a:spcBef>
-                <a:spcPts val="0"/>
-              </a:spcBef>
-              <a:spcAft>
-                <a:spcPts val="400"/>
-              </a:spcAft>
-              <a:buNone/>
-              <a:defRPr sz="1800" b="0">
-                <a:solidFill>
-                  <a:srgbClr val="303437"/>
-                </a:solidFill>
-                <a:latin typeface="Noto Sans"/>
-              </a:defRPr>
-            </a:pPr>
-            <a:r>
-              <a:rPr sz="1800" b="1" lang="ja-JP" altLang="en-US">
-                <a:solidFill>
-                  <a:srgbClr val="303437"/>
-                </a:solidFill>
-                <a:latin typeface="Noto Sans"/>
-                <a:ea typeface="Noto Sans CJK JP"/>
-                <a:cs typeface="Noto Sans"/>
-              </a:rPr>
-              <a:t>HELM: CLEVA dialogue generation scenario</a:t>
-            </a:r>
-          </a:p>
-          <a:p>
-            <a:pPr algn="l">
-              <a:lnSpc>
-                <a:spcPct val="114000"/>
-              </a:lnSpc>
-              <a:spcBef>
-                <a:spcPts val="0"/>
-              </a:spcBef>
-              <a:spcAft>
-                <a:spcPts val="500"/>
-              </a:spcAft>
-              <a:buNone/>
-              <a:defRPr sz="1250" b="0">
-                <a:solidFill>
-                  <a:srgbClr val="303437"/>
-                </a:solidFill>
-                <a:latin typeface="Noto Sans"/>
-              </a:defRPr>
-            </a:pPr>
-            <a:r>
-              <a:rPr sz="1250" b="0" lang="ja-JP" altLang="en-US">
-                <a:solidFill>
-                  <a:srgbClr val="626669"/>
-                </a:solidFill>
-                <a:latin typeface="Noto Sans"/>
-                <a:ea typeface="Noto Sans CJK JP"/>
-                <a:cs typeface="Noto Sans"/>
-              </a:rPr>
-              <a:t>Stanford CRFM (2023). HELM v0.4.0.</a:t>
-            </a:r>
-          </a:p>
-          <a:p>
-            <a:pPr algn="l">
-              <a:lnSpc>
-                <a:spcPct val="114000"/>
-              </a:lnSpc>
-              <a:spcBef>
-                <a:spcPts val="0"/>
-              </a:spcBef>
-              <a:spcAft>
-                <a:spcPts val="400"/>
-              </a:spcAft>
-              <a:buNone/>
-              <a:defRPr sz="1750" b="0">
-                <a:solidFill>
-                  <a:srgbClr val="303437"/>
-                </a:solidFill>
-                <a:latin typeface="Noto Sans"/>
-              </a:defRPr>
-            </a:pPr>
-            <a:r>
-              <a:rPr sz="1750" b="0" lang="ja-JP" altLang="en-US">
-                <a:solidFill>
-                  <a:srgbClr val="303437"/>
-                </a:solidFill>
-                <a:latin typeface="Noto Sans"/>
-                <a:ea typeface="Noto Sans CJK JP"/>
-                <a:cs typeface="Noto Sans"/>
-              </a:rPr>
-              <a:t>会話履歴と次の応答を組み合わせ、中国語モデルの応答生成に使う実装。</a:t>
-            </a:r>
-          </a:p>
-          <a:p>
-            <a:pPr algn="l">
-              <a:lnSpc>
-                <a:spcPct val="114000"/>
-              </a:lnSpc>
-              <a:spcBef>
-                <a:spcPts val="0"/>
-              </a:spcBef>
-              <a:spcAft>
-                <a:spcPts val="0"/>
-              </a:spcAft>
-              <a:buNone/>
-              <a:defRPr sz="1050" b="0">
-                <a:solidFill>
-                  <a:srgbClr val="303437"/>
-                </a:solidFill>
-                <a:latin typeface="Noto Sans"/>
-              </a:defRPr>
-            </a:pPr>
-            <a:r>
-              <a:rPr sz="1050" b="0" lang="ja-JP" altLang="en-US">
-                <a:solidFill>
-                  <a:srgbClr val="626669"/>
-                </a:solidFill>
-                <a:latin typeface="Noto Sans"/>
-                <a:ea typeface="Noto Sans CJK JP"/>
-                <a:cs typeface="Noto Sans"/>
-                <a:hlinkClick r:id="rId3"/>
-              </a:rPr>
-              <a:t>https://github.com/stanford-crfm/helm/blob/v0.4.0/src/helm/benchmark/scenarios/cleva_scenario.py</a:t>
             </a:r>
           </a:p>
         </p:txBody>

</xml_diff>